<commit_message>
M17: Sim-Review umgesetzt (sim_review true, Inhalt aktualisiert)
Co-Authored-By: Claude Opus 4.8 <noreply@anthropic.com>
</commit_message>
<xml_diff>
--- a/protected-downloads/praesentation/M17.pptx
+++ b/protected-downloads/praesentation/M17.pptx
@@ -8458,7 +8458,7 @@
                 </a:solidFill>
                 <a:latin typeface="Arial"/>
               </a:rPr>
-              <a:t>  Live-Demo II</a:t>
+              <a:t>  Offene Fragen aus Übung I (Puffer)</a:t>
             </a:r>
             <a:r>
               <a:rPr sz="900">
@@ -8467,7 +8467,7 @@
                 </a:solidFill>
                 <a:latin typeface="Arial"/>
               </a:rPr>
-              <a:t>  ·  Beamer-Demo</a:t>
+              <a:t>  ·  Plenum</a:t>
             </a:r>
           </a:p>
           <a:p>
@@ -8486,7 +8486,7 @@
                 </a:solidFill>
                 <a:latin typeface="Consolas"/>
               </a:rPr>
-              <a:t>01:15       </a:t>
+              <a:t>01:10       </a:t>
             </a:r>
             <a:r>
               <a:rPr sz="1200" b="1">
@@ -8495,7 +8495,7 @@
                 </a:solidFill>
                 <a:latin typeface="Arial"/>
               </a:rPr>
-              <a:t>  Einzelübung II</a:t>
+              <a:t>  Live-Demo II</a:t>
             </a:r>
             <a:r>
               <a:rPr sz="900">
@@ -8504,7 +8504,7 @@
                 </a:solidFill>
                 <a:latin typeface="Arial"/>
               </a:rPr>
-              <a:t>  ·  agree-Einzelarbeit</a:t>
+              <a:t>  ·  Beamer-Demo</a:t>
             </a:r>
           </a:p>
           <a:p>
@@ -8523,7 +8523,7 @@
                 </a:solidFill>
                 <a:latin typeface="Consolas"/>
               </a:rPr>
-              <a:t>01:30       </a:t>
+              <a:t>01:20       </a:t>
             </a:r>
             <a:r>
               <a:rPr sz="1200" b="1">
@@ -8532,7 +8532,7 @@
                 </a:solidFill>
                 <a:latin typeface="Arial"/>
               </a:rPr>
-              <a:t>  Reflexion: Meine Zeitfresser</a:t>
+              <a:t>  Einzelübung II</a:t>
             </a:r>
             <a:r>
               <a:rPr sz="900">
@@ -8541,7 +8541,7 @@
                 </a:solidFill>
                 <a:latin typeface="Arial"/>
               </a:rPr>
-              <a:t>  ·  Einzelarbeit</a:t>
+              <a:t>  ·  agree-Einzelarbeit</a:t>
             </a:r>
           </a:p>
           <a:p>
@@ -8569,7 +8569,7 @@
                 </a:solidFill>
                 <a:latin typeface="Arial"/>
               </a:rPr>
-              <a:t>  Abschluss &amp; Transfer</a:t>
+              <a:t>  Reflexion: Meine Zeitfresser</a:t>
             </a:r>
             <a:r>
               <a:rPr sz="900">
@@ -8578,7 +8578,7 @@
                 </a:solidFill>
                 <a:latin typeface="Arial"/>
               </a:rPr>
-              <a:t>  ·  Plenum</a:t>
+              <a:t>  ·  Einzelarbeit</a:t>
             </a:r>
           </a:p>
           <a:p>
@@ -8597,7 +8597,7 @@
                 </a:solidFill>
                 <a:latin typeface="Consolas"/>
               </a:rPr>
-              <a:t>01:42       </a:t>
+              <a:t>01:40       </a:t>
             </a:r>
             <a:r>
               <a:rPr sz="1200" b="1">
@@ -8606,7 +8606,7 @@
                 </a:solidFill>
                 <a:latin typeface="Arial"/>
               </a:rPr>
-              <a:t>  Feedbackbogen</a:t>
+              <a:t>  Abschluss &amp; Transfer</a:t>
             </a:r>
             <a:r>
               <a:rPr sz="900">
@@ -8615,7 +8615,7 @@
                 </a:solidFill>
                 <a:latin typeface="Arial"/>
               </a:rPr>
-              <a:t>  ·  Einzeln</a:t>
+              <a:t>  ·  Plenum</a:t>
             </a:r>
           </a:p>
           <a:p>
@@ -8634,7 +8634,44 @@
                 </a:solidFill>
                 <a:latin typeface="Consolas"/>
               </a:rPr>
-              <a:t>01:45       </a:t>
+              <a:t>01:47       </a:t>
+            </a:r>
+            <a:r>
+              <a:rPr sz="1200" b="1">
+                <a:solidFill>
+                  <a:srgbClr val="3D5466"/>
+                </a:solidFill>
+                <a:latin typeface="Arial"/>
+              </a:rPr>
+              <a:t>  Feedbackbogen</a:t>
+            </a:r>
+            <a:r>
+              <a:rPr sz="900">
+                <a:solidFill>
+                  <a:srgbClr val="78808C"/>
+                </a:solidFill>
+                <a:latin typeface="Arial"/>
+              </a:rPr>
+              <a:t>  ·  Einzeln</a:t>
+            </a:r>
+          </a:p>
+          <a:p>
+            <a:pPr>
+              <a:spcBef>
+                <a:spcPts val="400"/>
+              </a:spcBef>
+              <a:spcAft>
+                <a:spcPts val="100"/>
+              </a:spcAft>
+            </a:pPr>
+            <a:r>
+              <a:rPr sz="900">
+                <a:solidFill>
+                  <a:srgbClr val="78808C"/>
+                </a:solidFill>
+                <a:latin typeface="Consolas"/>
+              </a:rPr>
+              <a:t>01:50       </a:t>
             </a:r>
             <a:r>
               <a:rPr sz="1200" b="1">

</xml_diff>

<commit_message>
M-Track Batch 3: M17 Deck (Web/Workbook)
Co-Authored-By: Claude Fable 5 <noreply@anthropic.com>
</commit_message>
<xml_diff>
--- a/protected-downloads/praesentation/M17.pptx
+++ b/protected-downloads/praesentation/M17.pptx
@@ -18,7 +18,6 @@
     <p:sldId id="266" r:id="rId18"/>
     <p:sldId id="267" r:id="rId19"/>
     <p:sldId id="268" r:id="rId20"/>
-    <p:sldId id="269" r:id="rId21"/>
   </p:sldIdLst>
   <p:sldSz cx="12188952" cy="6858000" type="screen4x3"/>
   <p:notesSz cx="6858000" cy="9144000"/>
@@ -585,7 +584,7 @@
           <a:lstStyle/>
           <a:p>
             <a:r>
-              <a:t>Siehe Trainerhandbuch (Sektion 3) für Moderationshinweise, Timing und erwartete Teilnehmerreaktionen.</a:t>
+              <a:t>Einstieg: „Wie viel Zeit vor und nach einem Jahresgespräch verbringen Sie heute im System?"</a:t>
             </a:r>
           </a:p>
         </p:txBody>
@@ -655,7 +654,7 @@
           <a:lstStyle/>
           <a:p>
             <a:r>
-              <a:t>Siehe Trainerhandbuch (Sektion 3) für Moderationshinweise, Timing und erwartete Teilnehmerreaktionen.</a:t>
+              <a:t>Die Kernbereiche als Landkarte – wer sie kennt, findet für jede Aufgabe den richtigen Ort.</a:t>
             </a:r>
           </a:p>
         </p:txBody>
@@ -725,7 +724,7 @@
           <a:lstStyle/>
           <a:p>
             <a:r>
-              <a:t>Siehe Trainerhandbuch (Sektion 3) für Moderationshinweise, Timing und erwartete Teilnehmerreaktionen.</a:t>
+              <a:t>Kernbotschaft: die Zeitersparnis entsteht durch Routine, nicht durch Tempo.</a:t>
             </a:r>
           </a:p>
         </p:txBody>
@@ -795,7 +794,7 @@
           <a:lstStyle/>
           <a:p>
             <a:r>
-              <a:t>Siehe Trainerhandbuch (Sektion 3) für Moderationshinweise, Timing und erwartete Teilnehmerreaktionen.</a:t>
+              <a:t>Reporting-Cockpits und VR-NetWorld ergänzen: was wann wozu abrufen?</a:t>
             </a:r>
           </a:p>
         </p:txBody>
@@ -865,7 +864,7 @@
           <a:lstStyle/>
           <a:p>
             <a:r>
-              <a:t>Siehe Trainerhandbuch (Sektion 3) für Moderationshinweise, Timing und erwartete Teilnehmerreaktionen.</a:t>
+              <a:t>Der Praxiscase führt einmal den kompletten Workflow durch – von der Vorbereitung bis zur Wiedervorlage.</a:t>
             </a:r>
           </a:p>
         </p:txBody>
@@ -935,7 +934,7 @@
           <a:lstStyle/>
           <a:p>
             <a:r>
-              <a:t>Siehe Trainerhandbuch (Sektion 3) für Moderationshinweise, Timing und erwartete Teilnehmerreaktionen.</a:t>
+              <a:t>Überleitung zum Optimierungsplan und Selbstcheck.</a:t>
             </a:r>
           </a:p>
         </p:txBody>
@@ -1005,7 +1004,7 @@
           <a:lstStyle/>
           <a:p>
             <a:r>
-              <a:t>Siehe Trainerhandbuch (Sektion 3) für Moderationshinweise, Timing und erwartete Teilnehmerreaktionen.</a:t>
+              <a:t>Workflow-Optimierungsplan und Selbstcheck als Transferanker.</a:t>
             </a:r>
           </a:p>
         </p:txBody>
@@ -4601,7 +4600,7 @@
             <a:avLst/>
           </a:prstGeom>
           <a:solidFill>
-            <a:srgbClr val="EDEDF3"/>
+            <a:srgbClr val="1F2C56"/>
           </a:solidFill>
           <a:ln>
             <a:noFill/>
@@ -4631,57 +4630,14 @@
       </p:sp>
       <p:sp>
         <p:nvSpPr>
-          <p:cNvPr id="3" name="Rectangle 2"/>
-          <p:cNvSpPr/>
-          <p:nvPr/>
-        </p:nvSpPr>
-        <p:spPr>
-          <a:xfrm>
-            <a:off x="0" y="0"/>
-            <a:ext cx="12188952" cy="50292"/>
-          </a:xfrm>
-          <a:prstGeom prst="rect">
-            <a:avLst/>
-          </a:prstGeom>
-          <a:solidFill>
-            <a:srgbClr val="1F2C56"/>
-          </a:solidFill>
-          <a:ln>
-            <a:noFill/>
-          </a:ln>
-        </p:spPr>
-        <p:style>
-          <a:lnRef idx="1">
-            <a:schemeClr val="accent1"/>
-          </a:lnRef>
-          <a:fillRef idx="3">
-            <a:schemeClr val="accent1"/>
-          </a:fillRef>
-          <a:effectRef idx="2">
-            <a:schemeClr val="accent1"/>
-          </a:effectRef>
-          <a:fontRef idx="minor">
-            <a:schemeClr val="lt1"/>
-          </a:fontRef>
-        </p:style>
-        <p:txBody>
-          <a:bodyPr rtlCol="0" anchor="ctr"/>
-          <a:lstStyle/>
-          <a:p>
-            <a:pPr algn="ctr"/>
-          </a:p>
-        </p:txBody>
-      </p:sp>
-      <p:sp>
-        <p:nvSpPr>
-          <p:cNvPr id="4" name="TextBox 3"/>
+          <p:cNvPr id="3" name="TextBox 2"/>
           <p:cNvSpPr txBox="1"/>
           <p:nvPr/>
         </p:nvSpPr>
         <p:spPr>
           <a:xfrm>
-            <a:off x="685800" y="109728"/>
-            <a:ext cx="10817352" cy="228600"/>
+            <a:off x="685800" y="2377440"/>
+            <a:ext cx="10817352" cy="365760"/>
           </a:xfrm>
           <a:prstGeom prst="rect">
             <a:avLst/>
@@ -4696,70 +4652,27 @@
           <a:p>
             <a:pPr algn="l"/>
             <a:r>
-              <a:rPr sz="750">
-                <a:solidFill>
-                  <a:srgbClr val="78808C"/>
+              <a:rPr sz="1200">
+                <a:solidFill>
+                  <a:srgbClr val="D9C089"/>
                 </a:solidFill>
                 <a:latin typeface="Consolas"/>
               </a:rPr>
-              <a:t>M17  ·  INHALT</a:t>
-            </a:r>
-          </a:p>
-        </p:txBody>
-      </p:sp>
-      <p:sp>
-        <p:nvSpPr>
-          <p:cNvPr id="5" name="Rectangle 4"/>
+              <a:t>FALLARBEIT</a:t>
+            </a:r>
+          </a:p>
+        </p:txBody>
+      </p:sp>
+      <p:sp>
+        <p:nvSpPr>
+          <p:cNvPr id="4" name="Rectangle 3"/>
           <p:cNvSpPr/>
           <p:nvPr/>
         </p:nvSpPr>
         <p:spPr>
           <a:xfrm>
-            <a:off x="0" y="1234440"/>
-            <a:ext cx="12188952" cy="12700"/>
-          </a:xfrm>
-          <a:prstGeom prst="rect">
-            <a:avLst/>
-          </a:prstGeom>
-          <a:solidFill>
-            <a:srgbClr val="D8DFE4"/>
-          </a:solidFill>
-          <a:ln>
-            <a:noFill/>
-          </a:ln>
-        </p:spPr>
-        <p:style>
-          <a:lnRef idx="1">
-            <a:schemeClr val="accent1"/>
-          </a:lnRef>
-          <a:fillRef idx="3">
-            <a:schemeClr val="accent1"/>
-          </a:fillRef>
-          <a:effectRef idx="2">
-            <a:schemeClr val="accent1"/>
-          </a:effectRef>
-          <a:fontRef idx="minor">
-            <a:schemeClr val="lt1"/>
-          </a:fontRef>
-        </p:style>
-        <p:txBody>
-          <a:bodyPr rtlCol="0" anchor="ctr"/>
-          <a:lstStyle/>
-          <a:p>
-            <a:pPr algn="ctr"/>
-          </a:p>
-        </p:txBody>
-      </p:sp>
-      <p:sp>
-        <p:nvSpPr>
-          <p:cNvPr id="6" name="Rectangle 5"/>
-          <p:cNvSpPr/>
-          <p:nvPr/>
-        </p:nvSpPr>
-        <p:spPr>
-          <a:xfrm>
-            <a:off x="685800" y="502920"/>
-            <a:ext cx="36576" cy="658368"/>
+            <a:off x="685800" y="2788920"/>
+            <a:ext cx="548640" cy="38100"/>
           </a:xfrm>
           <a:prstGeom prst="rect">
             <a:avLst/>
@@ -4795,14 +4708,14 @@
       </p:sp>
       <p:sp>
         <p:nvSpPr>
-          <p:cNvPr id="7" name="TextBox 6"/>
+          <p:cNvPr id="5" name="TextBox 4"/>
           <p:cNvSpPr txBox="1"/>
           <p:nvPr/>
         </p:nvSpPr>
         <p:spPr>
           <a:xfrm>
-            <a:off x="813816" y="502920"/>
-            <a:ext cx="10634472" cy="685800"/>
+            <a:off x="685800" y="3017520"/>
+            <a:ext cx="10817352" cy="1463040"/>
           </a:xfrm>
           <a:prstGeom prst="rect">
             <a:avLst/>
@@ -4817,27 +4730,27 @@
           <a:p>
             <a:pPr algn="l"/>
             <a:r>
-              <a:rPr sz="2400" b="1" i="0">
-                <a:solidFill>
-                  <a:srgbClr val="1F2C56"/>
+              <a:rPr sz="4000" b="1" i="0">
+                <a:solidFill>
+                  <a:srgbClr val="FFFFFF"/>
                 </a:solidFill>
                 <a:latin typeface="Arial"/>
               </a:rPr>
-              <a:t>Die Bedarfsdimensionen im UnternehmerDialog</a:t>
-            </a:r>
-          </a:p>
-        </p:txBody>
-      </p:sp>
-      <p:sp>
-        <p:nvSpPr>
-          <p:cNvPr id="8" name="TextBox 7"/>
+              <a:t>Praxiscase</a:t>
+            </a:r>
+          </a:p>
+        </p:txBody>
+      </p:sp>
+      <p:sp>
+        <p:nvSpPr>
+          <p:cNvPr id="6" name="TextBox 5"/>
           <p:cNvSpPr txBox="1"/>
           <p:nvPr/>
         </p:nvSpPr>
         <p:spPr>
           <a:xfrm>
-            <a:off x="685800" y="1417320"/>
-            <a:ext cx="10817352" cy="4892040"/>
+            <a:off x="685800" y="4480560"/>
+            <a:ext cx="8653881" cy="1280160"/>
           </a:xfrm>
           <a:prstGeom prst="rect">
             <a:avLst/>
@@ -4845,103 +4758,34 @@
           <a:noFill/>
         </p:spPr>
         <p:txBody>
-          <a:bodyPr wrap="square" anchor="ctr">
+          <a:bodyPr wrap="square">
             <a:spAutoFit/>
           </a:bodyPr>
           <a:lstStyle/>
           <a:p>
-            <a:pPr marL="190500" indent="-190500">
-              <a:spcBef>
-                <a:spcPts val="400"/>
-              </a:spcBef>
-              <a:spcAft>
-                <a:spcPts val="200"/>
-              </a:spcAft>
-            </a:pPr>
-            <a:r>
-              <a:rPr sz="1300">
-                <a:solidFill>
-                  <a:srgbClr val="3D5466"/>
+            <a:pPr algn="l"/>
+            <a:r>
+              <a:rPr sz="1600" b="0" i="0">
+                <a:solidFill>
+                  <a:srgbClr val="C8D2E6"/>
                 </a:solidFill>
                 <a:latin typeface="Arial"/>
               </a:rPr>
-              <a:t>▸  (Bezeichnungen entsprechen der agree-Standardstruktur; in Ihrer Bankinstallation können einzelne Felder abweichend benannt sein)</a:t>
-            </a:r>
-          </a:p>
-          <a:p>
-            <a:pPr marL="190500" indent="-190500">
-              <a:spcBef>
-                <a:spcPts val="400"/>
-              </a:spcBef>
-              <a:spcAft>
-                <a:spcPts val="200"/>
-              </a:spcAft>
-            </a:pPr>
-            <a:r>
-              <a:rPr sz="1300">
-                <a:solidFill>
-                  <a:srgbClr val="3D5466"/>
-                </a:solidFill>
-                <a:latin typeface="Arial"/>
-              </a:rPr>
-              <a:t>▸  Wichtig: Nicht alle Dimensionen in jedem Gespräch vollständig abarbeiten. Priorität setzen – zwei oder drei Dimensionen pro Gespräch vertiefen.</a:t>
-            </a:r>
-          </a:p>
-        </p:txBody>
-      </p:sp>
-      <p:sp>
-        <p:nvSpPr>
-          <p:cNvPr id="9" name="Rectangle 8"/>
-          <p:cNvSpPr/>
-          <p:nvPr/>
-        </p:nvSpPr>
-        <p:spPr>
-          <a:xfrm>
-            <a:off x="0" y="6510528"/>
-            <a:ext cx="12188952" cy="347472"/>
-          </a:xfrm>
-          <a:prstGeom prst="rect">
-            <a:avLst/>
-          </a:prstGeom>
-          <a:solidFill>
-            <a:srgbClr val="0A1937"/>
-          </a:solidFill>
-          <a:ln>
-            <a:noFill/>
-          </a:ln>
-        </p:spPr>
-        <p:style>
-          <a:lnRef idx="1">
-            <a:schemeClr val="accent1"/>
-          </a:lnRef>
-          <a:fillRef idx="3">
-            <a:schemeClr val="accent1"/>
-          </a:fillRef>
-          <a:effectRef idx="2">
-            <a:schemeClr val="accent1"/>
-          </a:effectRef>
-          <a:fontRef idx="minor">
-            <a:schemeClr val="lt1"/>
-          </a:fontRef>
-        </p:style>
-        <p:txBody>
-          <a:bodyPr rtlCol="0" anchor="ctr"/>
-          <a:lstStyle/>
-          <a:p>
-            <a:pPr algn="ctr"/>
-          </a:p>
-        </p:txBody>
-      </p:sp>
-      <p:sp>
-        <p:nvSpPr>
-          <p:cNvPr id="10" name="TextBox 9"/>
+              <a:t>Ein Jahresgespräch von A bis Z effizient in agree abbilden.</a:t>
+            </a:r>
+          </a:p>
+        </p:txBody>
+      </p:sp>
+      <p:sp>
+        <p:nvSpPr>
+          <p:cNvPr id="7" name="TextBox 6"/>
           <p:cNvSpPr txBox="1"/>
           <p:nvPr/>
         </p:nvSpPr>
         <p:spPr>
           <a:xfrm>
-            <a:off x="685800" y="6583680"/>
-            <a:ext cx="6490411" cy="256032"/>
+            <a:off x="685800" y="6355080"/>
+            <a:ext cx="10817352" cy="274320"/>
           </a:xfrm>
           <a:prstGeom prst="rect">
             <a:avLst/>
@@ -4958,7 +4802,7 @@
             <a:r>
               <a:rPr sz="700">
                 <a:solidFill>
-                  <a:srgbClr val="A0B4D2"/>
+                  <a:srgbClr val="8CA0C3"/>
                 </a:solidFill>
                 <a:latin typeface="Consolas"/>
               </a:rPr>
@@ -5101,7 +4945,7 @@
                 </a:solidFill>
                 <a:latin typeface="Consolas"/>
               </a:rPr>
-              <a:t>M17  ·  INHALT</a:t>
+              <a:t>M17  ·  ARBEITSBLATT</a:t>
             </a:r>
           </a:p>
         </p:txBody>
@@ -5222,7 +5066,7 @@
                 </a:solidFill>
                 <a:latin typeface="Arial"/>
               </a:rPr>
-              <a:t>Dokumentationsstandards</a:t>
+              <a:t>Ein Jahresgespräch von A bis Z bearbeiten</a:t>
             </a:r>
           </a:p>
         </p:txBody>
@@ -5235,8 +5079,8 @@
         </p:nvSpPr>
         <p:spPr>
           <a:xfrm>
-            <a:off x="685800" y="1417320"/>
-            <a:ext cx="10817352" cy="4892040"/>
+            <a:off x="685800" y="1554480"/>
+            <a:ext cx="10817352" cy="3840480"/>
           </a:xfrm>
           <a:prstGeom prst="rect">
             <a:avLst/>
@@ -5258,13 +5102,13 @@
               </a:spcAft>
             </a:pPr>
             <a:r>
-              <a:rPr sz="1300">
+              <a:rPr sz="1400">
                 <a:solidFill>
                   <a:srgbClr val="3D5466"/>
                 </a:solidFill>
                 <a:latin typeface="Arial"/>
               </a:rPr>
-              <a:t>▸  Datum, Teilnehmer, Gesprächsanlass</a:t>
+              <a:t>▸  Führen Sie Ihren agree-Selbstcheck durch (AB-1).</a:t>
             </a:r>
           </a:p>
           <a:p>
@@ -5277,13 +5121,13 @@
               </a:spcAft>
             </a:pPr>
             <a:r>
-              <a:rPr sz="1300">
+              <a:rPr sz="1400">
                 <a:solidFill>
                   <a:srgbClr val="3D5466"/>
                 </a:solidFill>
                 <a:latin typeface="Arial"/>
               </a:rPr>
-              <a:t>▸  Besprochene Bedarfsdimensionen mit Ergebnis (Bedarf vorhanden / kein Bedarf / offen)</a:t>
+              <a:t>▸  Bilden Sie ein vollständiges Jahresgespräch (Vor–Während–Nach) im System ab.</a:t>
             </a:r>
           </a:p>
           <a:p>
@@ -5296,191 +5140,98 @@
               </a:spcAft>
             </a:pPr>
             <a:r>
-              <a:rPr sz="1300">
+              <a:rPr sz="1400">
                 <a:solidFill>
                   <a:srgbClr val="3D5466"/>
                 </a:solidFill>
                 <a:latin typeface="Arial"/>
               </a:rPr>
-              <a:t>▸  Vereinbarte Maßnahmen mit Termin</a:t>
-            </a:r>
-          </a:p>
-          <a:p>
-            <a:pPr marL="190500" indent="-190500">
-              <a:spcBef>
-                <a:spcPts val="400"/>
-              </a:spcBef>
-              <a:spcAft>
-                <a:spcPts val="200"/>
-              </a:spcAft>
-            </a:pPr>
-            <a:r>
-              <a:rPr sz="1300">
-                <a:solidFill>
-                  <a:srgbClr val="3D5466"/>
+              <a:t>▸  Entwickeln Sie Ihren persönlichen Workflow-Optimierungsplan (AB-2).</a:t>
+            </a:r>
+          </a:p>
+        </p:txBody>
+      </p:sp>
+      <p:sp>
+        <p:nvSpPr>
+          <p:cNvPr id="9" name="Rectangle 8"/>
+          <p:cNvSpPr/>
+          <p:nvPr/>
+        </p:nvSpPr>
+        <p:spPr>
+          <a:xfrm>
+            <a:off x="685800" y="5486400"/>
+            <a:ext cx="10817352" cy="640080"/>
+          </a:xfrm>
+          <a:prstGeom prst="rect">
+            <a:avLst/>
+          </a:prstGeom>
+          <a:solidFill>
+            <a:srgbClr val="1F2C56"/>
+          </a:solidFill>
+          <a:ln>
+            <a:noFill/>
+          </a:ln>
+        </p:spPr>
+        <p:style>
+          <a:lnRef idx="1">
+            <a:schemeClr val="accent1"/>
+          </a:lnRef>
+          <a:fillRef idx="3">
+            <a:schemeClr val="accent1"/>
+          </a:fillRef>
+          <a:effectRef idx="2">
+            <a:schemeClr val="accent1"/>
+          </a:effectRef>
+          <a:fontRef idx="minor">
+            <a:schemeClr val="lt1"/>
+          </a:fontRef>
+        </p:style>
+        <p:txBody>
+          <a:bodyPr rtlCol="0" anchor="ctr"/>
+          <a:lstStyle/>
+          <a:p>
+            <a:pPr algn="ctr"/>
+          </a:p>
+        </p:txBody>
+      </p:sp>
+      <p:sp>
+        <p:nvSpPr>
+          <p:cNvPr id="10" name="TextBox 9"/>
+          <p:cNvSpPr txBox="1"/>
+          <p:nvPr/>
+        </p:nvSpPr>
+        <p:spPr>
+          <a:xfrm>
+            <a:off x="868680" y="5596128"/>
+            <a:ext cx="10451592" cy="457200"/>
+          </a:xfrm>
+          <a:prstGeom prst="rect">
+            <a:avLst/>
+          </a:prstGeom>
+          <a:noFill/>
+        </p:spPr>
+        <p:txBody>
+          <a:bodyPr wrap="square">
+            <a:spAutoFit/>
+          </a:bodyPr>
+          <a:lstStyle/>
+          <a:p>
+            <a:pPr algn="l"/>
+            <a:r>
+              <a:rPr sz="1300" b="1" i="0">
+                <a:solidFill>
+                  <a:srgbClr val="FFFFFF"/>
                 </a:solidFill>
                 <a:latin typeface="Arial"/>
               </a:rPr>
-              <a:t>▸  Folgeaktivitäten angelegt</a:t>
-            </a:r>
-          </a:p>
-          <a:p>
-            <a:pPr marL="190500" indent="-190500">
-              <a:spcBef>
-                <a:spcPts val="400"/>
-              </a:spcBef>
-              <a:spcAft>
-                <a:spcPts val="200"/>
-              </a:spcAft>
-            </a:pPr>
-            <a:r>
-              <a:rPr sz="1300">
-                <a:solidFill>
-                  <a:srgbClr val="3D5466"/>
-                </a:solidFill>
-                <a:latin typeface="Arial"/>
-              </a:rPr>
-              <a:t>▸  ## 4.4 Reporting-Cockpits: Was wann wozu?</a:t>
-            </a:r>
-          </a:p>
-          <a:p>
-            <a:pPr marL="190500" indent="-190500">
-              <a:spcBef>
-                <a:spcPts val="400"/>
-              </a:spcBef>
-              <a:spcAft>
-                <a:spcPts val="200"/>
-              </a:spcAft>
-            </a:pPr>
-            <a:r>
-              <a:rPr sz="1300">
-                <a:solidFill>
-                  <a:srgbClr val="3D5466"/>
-                </a:solidFill>
-                <a:latin typeface="Arial"/>
-              </a:rPr>
-              <a:t>▸  Empfehlung – Die 15-Minuten-Morgenroutine:</a:t>
-            </a:r>
-          </a:p>
-          <a:p>
-            <a:pPr marL="190500" indent="-190500">
-              <a:spcBef>
-                <a:spcPts val="400"/>
-              </a:spcBef>
-              <a:spcAft>
-                <a:spcPts val="200"/>
-              </a:spcAft>
-            </a:pPr>
-            <a:r>
-              <a:rPr sz="1300">
-                <a:solidFill>
-                  <a:srgbClr val="3D5466"/>
-                </a:solidFill>
-                <a:latin typeface="Arial"/>
-              </a:rPr>
-              <a:t>▸  Aktivitätenübersicht: Welche Aufgaben sind heute fällig? (3 Min.)</a:t>
-            </a:r>
-          </a:p>
-          <a:p>
-            <a:pPr marL="190500" indent="-190500">
-              <a:spcBef>
-                <a:spcPts val="400"/>
-              </a:spcBef>
-              <a:spcAft>
-                <a:spcPts val="200"/>
-              </a:spcAft>
-            </a:pPr>
-            <a:r>
-              <a:rPr sz="1300">
-                <a:solidFill>
-                  <a:srgbClr val="3D5466"/>
-                </a:solidFill>
-                <a:latin typeface="Arial"/>
-              </a:rPr>
-              <a:t>▸  Frühwarnliste: Neue Hinweise? (5 Min.)</a:t>
-            </a:r>
-          </a:p>
-          <a:p>
-            <a:pPr marL="190500" indent="-190500">
-              <a:spcBef>
-                <a:spcPts val="400"/>
-              </a:spcBef>
-              <a:spcAft>
-                <a:spcPts val="200"/>
-              </a:spcAft>
-            </a:pPr>
-            <a:r>
-              <a:rPr sz="1300">
-                <a:solidFill>
-                  <a:srgbClr val="3D5466"/>
-                </a:solidFill>
-                <a:latin typeface="Arial"/>
-              </a:rPr>
-              <a:t>▸  Prolongationsübersicht: Fälligkeiten in den nächsten 30 Tagen? (3 Min.)</a:t>
-            </a:r>
-          </a:p>
-          <a:p>
-            <a:pPr marL="190500" indent="-190500">
-              <a:spcBef>
-                <a:spcPts val="400"/>
-              </a:spcBef>
-              <a:spcAft>
-                <a:spcPts val="200"/>
-              </a:spcAft>
-            </a:pPr>
-            <a:r>
-              <a:rPr sz="1300">
-                <a:solidFill>
-                  <a:srgbClr val="3D5466"/>
-                </a:solidFill>
-                <a:latin typeface="Arial"/>
-              </a:rPr>
-              <a:t>▸  E-Mail an Verbundpartner zu offenen Übergaben? (4 Min.)</a:t>
-            </a:r>
-          </a:p>
-          <a:p>
-            <a:pPr marL="190500" indent="-190500">
-              <a:spcBef>
-                <a:spcPts val="400"/>
-              </a:spcBef>
-              <a:spcAft>
-                <a:spcPts val="200"/>
-              </a:spcAft>
-            </a:pPr>
-            <a:r>
-              <a:rPr sz="1300">
-                <a:solidFill>
-                  <a:srgbClr val="3D5466"/>
-                </a:solidFill>
-                <a:latin typeface="Arial"/>
-              </a:rPr>
-              <a:t>▸  Diese Routine hält den Bestand im Griff – ohne aufwendige Recherche.</a:t>
-            </a:r>
-          </a:p>
-          <a:p>
-            <a:pPr marL="190500" indent="-190500">
-              <a:spcBef>
-                <a:spcPts val="400"/>
-              </a:spcBef>
-              <a:spcAft>
-                <a:spcPts val="200"/>
-              </a:spcAft>
-            </a:pPr>
-            <a:r>
-              <a:rPr sz="1300">
-                <a:solidFill>
-                  <a:srgbClr val="3D5466"/>
-                </a:solidFill>
-                <a:latin typeface="Arial"/>
-              </a:rPr>
-              <a:t>▸  ## 4.5 VR-NetWorld und Verbundpartner-Systeme</a:t>
-            </a:r>
-          </a:p>
-        </p:txBody>
-      </p:sp>
-      <p:sp>
-        <p:nvSpPr>
-          <p:cNvPr id="9" name="Rectangle 8"/>
+              <a:t>→  Bearbeitung im Teilnehmer-Workbook (Arbeitsblatt mit Ausfüllfeldern)</a:t>
+            </a:r>
+          </a:p>
+        </p:txBody>
+      </p:sp>
+      <p:sp>
+        <p:nvSpPr>
+          <p:cNvPr id="11" name="Rectangle 10"/>
           <p:cNvSpPr/>
           <p:nvPr/>
         </p:nvSpPr>
@@ -5523,7 +5274,7 @@
       </p:sp>
       <p:sp>
         <p:nvSpPr>
-          <p:cNvPr id="10" name="TextBox 9"/>
+          <p:cNvPr id="12" name="TextBox 11"/>
           <p:cNvSpPr txBox="1"/>
           <p:nvPr/>
         </p:nvSpPr>
@@ -5811,7 +5562,7 @@
                 </a:solidFill>
                 <a:latin typeface="Arial"/>
               </a:rPr>
-              <a:t>AB-1: Mein agree-Selbstcheck</a:t>
+              <a:t>Prinzip dieses Moduls</a:t>
             </a:r>
           </a:p>
         </p:txBody>
@@ -5837,6 +5588,25 @@
             <a:spAutoFit/>
           </a:bodyPr>
           <a:lstStyle/>
+          <a:p>
+            <a:pPr marL="177800" indent="-177800">
+              <a:spcBef>
+                <a:spcPts val="600"/>
+              </a:spcBef>
+              <a:spcAft>
+                <a:spcPts val="200"/>
+              </a:spcAft>
+            </a:pPr>
+            <a:r>
+              <a:rPr sz="1200" i="1">
+                <a:solidFill>
+                  <a:srgbClr val="3D5466"/>
+                </a:solidFill>
+                <a:latin typeface="Arial"/>
+              </a:rPr>
+              <a:t>→  Das System soll dir Zeit fürs Gespräch schenken, nicht sie nehmen.</a:t>
+            </a:r>
+          </a:p>
           <a:p>
             <a:pPr marL="190500" indent="-190500">
               <a:spcBef>
@@ -5853,45 +5623,7 @@
                 </a:solidFill>
                 <a:latin typeface="Arial"/>
               </a:rPr>
-              <a:t>▸  Bewerten Sie Ihren aktuellen Umgang mit agree ehrlich (1 = nutze ich kaum / 5 = nutze ich routiniert):</a:t>
-            </a:r>
-          </a:p>
-          <a:p>
-            <a:pPr marL="190500" indent="-190500">
-              <a:spcBef>
-                <a:spcPts val="400"/>
-              </a:spcBef>
-              <a:spcAft>
-                <a:spcPts val="200"/>
-              </a:spcAft>
-            </a:pPr>
-            <a:r>
-              <a:rPr sz="1300">
-                <a:solidFill>
-                  <a:srgbClr val="3D5466"/>
-                </a:solidFill>
-                <a:latin typeface="Arial"/>
-              </a:rPr>
-              <a:t>▸  Meine zwei größten Zeitfresser im aktuellen Workflow:</a:t>
-            </a:r>
-          </a:p>
-          <a:p>
-            <a:pPr marL="190500" indent="-190500">
-              <a:spcBef>
-                <a:spcPts val="400"/>
-              </a:spcBef>
-              <a:spcAft>
-                <a:spcPts val="200"/>
-              </a:spcAft>
-            </a:pPr>
-            <a:r>
-              <a:rPr sz="1300">
-                <a:solidFill>
-                  <a:srgbClr val="3D5466"/>
-                </a:solidFill>
-                <a:latin typeface="Arial"/>
-              </a:rPr>
-              <a:t>▸  agree-Funktion, die ich morgen früh ausprobiere:</a:t>
+              <a:t>▸  Wer agree für Vorbereitung und Dokumentation beherrscht, gewinnt Minuten je Termin zurück – für den Kunden.</a:t>
             </a:r>
           </a:p>
         </p:txBody>
@@ -6007,7 +5739,7 @@
             <a:avLst/>
           </a:prstGeom>
           <a:solidFill>
-            <a:srgbClr val="FFFFFF"/>
+            <a:srgbClr val="EDEDF3"/>
           </a:solidFill>
           <a:ln>
             <a:noFill/>
@@ -6108,43 +5840,51 @@
                 </a:solidFill>
                 <a:latin typeface="Consolas"/>
               </a:rPr>
-              <a:t>M17  ·  ÜBERSICHT</a:t>
-            </a:r>
-          </a:p>
-        </p:txBody>
-      </p:sp>
-      <p:sp>
-        <p:nvSpPr>
-          <p:cNvPr id="5" name="TextBox 4"/>
-          <p:cNvSpPr txBox="1"/>
-          <p:nvPr/>
-        </p:nvSpPr>
-        <p:spPr>
-          <a:xfrm>
-            <a:off x="685800" y="502920"/>
-            <a:ext cx="10817352" cy="594360"/>
-          </a:xfrm>
-          <a:prstGeom prst="rect">
-            <a:avLst/>
-          </a:prstGeom>
-          <a:noFill/>
-        </p:spPr>
-        <p:txBody>
-          <a:bodyPr wrap="square">
-            <a:spAutoFit/>
-          </a:bodyPr>
-          <a:lstStyle/>
-          <a:p>
-            <a:pPr algn="l"/>
-            <a:r>
-              <a:rPr sz="2000" b="1" i="0">
-                <a:solidFill>
-                  <a:srgbClr val="1F2C56"/>
-                </a:solidFill>
-                <a:latin typeface="Arial"/>
-              </a:rPr>
-              <a:t>AB-1: Mein agree-Selbstcheck</a:t>
-            </a:r>
+              <a:t>M17  ·  INHALT</a:t>
+            </a:r>
+          </a:p>
+        </p:txBody>
+      </p:sp>
+      <p:sp>
+        <p:nvSpPr>
+          <p:cNvPr id="5" name="Rectangle 4"/>
+          <p:cNvSpPr/>
+          <p:nvPr/>
+        </p:nvSpPr>
+        <p:spPr>
+          <a:xfrm>
+            <a:off x="0" y="1234440"/>
+            <a:ext cx="12188952" cy="12700"/>
+          </a:xfrm>
+          <a:prstGeom prst="rect">
+            <a:avLst/>
+          </a:prstGeom>
+          <a:solidFill>
+            <a:srgbClr val="D8DFE4"/>
+          </a:solidFill>
+          <a:ln>
+            <a:noFill/>
+          </a:ln>
+        </p:spPr>
+        <p:style>
+          <a:lnRef idx="1">
+            <a:schemeClr val="accent1"/>
+          </a:lnRef>
+          <a:fillRef idx="3">
+            <a:schemeClr val="accent1"/>
+          </a:fillRef>
+          <a:effectRef idx="2">
+            <a:schemeClr val="accent1"/>
+          </a:effectRef>
+          <a:fontRef idx="minor">
+            <a:schemeClr val="lt1"/>
+          </a:fontRef>
+        </p:style>
+        <p:txBody>
+          <a:bodyPr rtlCol="0" anchor="ctr"/>
+          <a:lstStyle/>
+          <a:p>
+            <a:pPr algn="ctr"/>
           </a:p>
         </p:txBody>
       </p:sp>
@@ -6156,8 +5896,8 @@
         </p:nvSpPr>
         <p:spPr>
           <a:xfrm>
-            <a:off x="685800" y="1143000"/>
-            <a:ext cx="10817352" cy="25400"/>
+            <a:off x="685800" y="502920"/>
+            <a:ext cx="36576" cy="658368"/>
           </a:xfrm>
           <a:prstGeom prst="rect">
             <a:avLst/>
@@ -6191,356 +5931,124 @@
           </a:p>
         </p:txBody>
       </p:sp>
-      <p:graphicFrame>
-        <p:nvGraphicFramePr>
-          <p:cNvPr id="7" name="Table 6"/>
-          <p:cNvGraphicFramePr>
-            <a:graphicFrameLocks noGrp="1"/>
-          </p:cNvGraphicFramePr>
-          <p:nvPr/>
-        </p:nvGraphicFramePr>
-        <p:xfrm>
-          <a:off x="685800" y="1417320"/>
-          <a:ext cx="10817352" cy="3072384"/>
-        </p:xfrm>
-        <a:graphic>
-          <a:graphicData uri="http://schemas.openxmlformats.org/drawingml/2006/table">
-            <a:tbl>
-              <a:tblPr firstRow="1" bandRow="1">
-                <a:tableStyleId>{5C22544A-7EE6-4342-B048-85BDC9FD1C3A}</a:tableStyleId>
-              </a:tblPr>
-              <a:tblGrid>
-                <a:gridCol w="3605784"/>
-                <a:gridCol w="3605784"/>
-                <a:gridCol w="3605784"/>
-              </a:tblGrid>
-              <a:tr h="384048">
-                <a:tc>
-                  <a:txBody>
-                    <a:bodyPr/>
-                    <a:lstStyle/>
-                    <a:p>
-                      <a:r>
-                        <a:rPr sz="1100" b="1">
-                          <a:solidFill>
-                            <a:srgbClr val="FFFFFF"/>
-                          </a:solidFill>
-                          <a:latin typeface="Arial"/>
-                        </a:rPr>
-                        <a:t>agree-Bereich</a:t>
-                      </a:r>
-                    </a:p>
-                  </a:txBody>
-                  <a:tcPr>
-                    <a:solidFill>
-                      <a:srgbClr val="1F2C56"/>
-                    </a:solidFill>
-                  </a:tcPr>
-                </a:tc>
-                <a:tc>
-                  <a:txBody>
-                    <a:bodyPr/>
-                    <a:lstStyle/>
-                    <a:p>
-                      <a:r>
-                        <a:rPr sz="1100" b="1">
-                          <a:solidFill>
-                            <a:srgbClr val="FFFFFF"/>
-                          </a:solidFill>
-                          <a:latin typeface="Arial"/>
-                        </a:rPr>
-                        <a:t>Meine Nutzung (1–5)</a:t>
-                      </a:r>
-                    </a:p>
-                  </a:txBody>
-                  <a:tcPr>
-                    <a:solidFill>
-                      <a:srgbClr val="1F2C56"/>
-                    </a:solidFill>
-                  </a:tcPr>
-                </a:tc>
-                <a:tc>
-                  <a:txBody>
-                    <a:bodyPr/>
-                    <a:lstStyle/>
-                    <a:p>
-                      <a:r>
-                        <a:rPr sz="1100" b="1">
-                          <a:solidFill>
-                            <a:srgbClr val="FFFFFF"/>
-                          </a:solidFill>
-                          <a:latin typeface="Arial"/>
-                        </a:rPr>
-                        <a:t>Wichtigste Verbesserung</a:t>
-                      </a:r>
-                    </a:p>
-                  </a:txBody>
-                  <a:tcPr>
-                    <a:solidFill>
-                      <a:srgbClr val="1F2C56"/>
-                    </a:solidFill>
-                  </a:tcPr>
-                </a:tc>
-              </a:tr>
-              <a:tr h="384048">
-                <a:tc>
-                  <a:txBody>
-                    <a:bodyPr/>
-                    <a:lstStyle/>
-                    <a:p>
-                      <a:r>
-                        <a:rPr sz="1050">
-                          <a:solidFill>
-                            <a:srgbClr val="3D5466"/>
-                          </a:solidFill>
-                          <a:latin typeface="Arial"/>
-                        </a:rPr>
-                        <a:t>CRM / Kundenprofil</a:t>
-                      </a:r>
-                    </a:p>
-                  </a:txBody>
-                  <a:tcPr/>
-                </a:tc>
-                <a:tc>
-                  <a:txBody>
-                    <a:bodyPr/>
-                    <a:lstStyle/>
-                    <a:p/>
-                  </a:txBody>
-                  <a:tcPr/>
-                </a:tc>
-                <a:tc>
-                  <a:txBody>
-                    <a:bodyPr/>
-                    <a:lstStyle/>
-                    <a:p/>
-                  </a:txBody>
-                  <a:tcPr/>
-                </a:tc>
-              </a:tr>
-              <a:tr h="384048">
-                <a:tc>
-                  <a:txBody>
-                    <a:bodyPr/>
-                    <a:lstStyle/>
-                    <a:p>
-                      <a:r>
-                        <a:rPr sz="1050">
-                          <a:solidFill>
-                            <a:srgbClr val="3D5466"/>
-                          </a:solidFill>
-                          <a:latin typeface="Arial"/>
-                        </a:rPr>
-                        <a:t>UnternehmerDialog</a:t>
-                      </a:r>
-                    </a:p>
-                  </a:txBody>
-                  <a:tcPr/>
-                </a:tc>
-                <a:tc>
-                  <a:txBody>
-                    <a:bodyPr/>
-                    <a:lstStyle/>
-                    <a:p/>
-                  </a:txBody>
-                  <a:tcPr/>
-                </a:tc>
-                <a:tc>
-                  <a:txBody>
-                    <a:bodyPr/>
-                    <a:lstStyle/>
-                    <a:p/>
-                  </a:txBody>
-                  <a:tcPr/>
-                </a:tc>
-              </a:tr>
-              <a:tr h="384048">
-                <a:tc>
-                  <a:txBody>
-                    <a:bodyPr/>
-                    <a:lstStyle/>
-                    <a:p>
-                      <a:r>
-                        <a:rPr sz="1050">
-                          <a:solidFill>
-                            <a:srgbClr val="3D5466"/>
-                          </a:solidFill>
-                          <a:latin typeface="Arial"/>
-                        </a:rPr>
-                        <a:t>Kreditbearbeitung / Prolongation</a:t>
-                      </a:r>
-                    </a:p>
-                  </a:txBody>
-                  <a:tcPr/>
-                </a:tc>
-                <a:tc>
-                  <a:txBody>
-                    <a:bodyPr/>
-                    <a:lstStyle/>
-                    <a:p/>
-                  </a:txBody>
-                  <a:tcPr/>
-                </a:tc>
-                <a:tc>
-                  <a:txBody>
-                    <a:bodyPr/>
-                    <a:lstStyle/>
-                    <a:p/>
-                  </a:txBody>
-                  <a:tcPr/>
-                </a:tc>
-              </a:tr>
-              <a:tr h="384048">
-                <a:tc>
-                  <a:txBody>
-                    <a:bodyPr/>
-                    <a:lstStyle/>
-                    <a:p>
-                      <a:r>
-                        <a:rPr sz="1050">
-                          <a:solidFill>
-                            <a:srgbClr val="3D5466"/>
-                          </a:solidFill>
-                          <a:latin typeface="Arial"/>
-                        </a:rPr>
-                        <a:t>Controlling (NMZ, DB-Cockpit)</a:t>
-                      </a:r>
-                    </a:p>
-                  </a:txBody>
-                  <a:tcPr/>
-                </a:tc>
-                <a:tc>
-                  <a:txBody>
-                    <a:bodyPr/>
-                    <a:lstStyle/>
-                    <a:p/>
-                  </a:txBody>
-                  <a:tcPr/>
-                </a:tc>
-                <a:tc>
-                  <a:txBody>
-                    <a:bodyPr/>
-                    <a:lstStyle/>
-                    <a:p/>
-                  </a:txBody>
-                  <a:tcPr/>
-                </a:tc>
-              </a:tr>
-              <a:tr h="384048">
-                <a:tc>
-                  <a:txBody>
-                    <a:bodyPr/>
-                    <a:lstStyle/>
-                    <a:p>
-                      <a:r>
-                        <a:rPr sz="1050">
-                          <a:solidFill>
-                            <a:srgbClr val="3D5466"/>
-                          </a:solidFill>
-                          <a:latin typeface="Arial"/>
-                        </a:rPr>
-                        <a:t>Verbundpartner-Cockpit</a:t>
-                      </a:r>
-                    </a:p>
-                  </a:txBody>
-                  <a:tcPr/>
-                </a:tc>
-                <a:tc>
-                  <a:txBody>
-                    <a:bodyPr/>
-                    <a:lstStyle/>
-                    <a:p/>
-                  </a:txBody>
-                  <a:tcPr/>
-                </a:tc>
-                <a:tc>
-                  <a:txBody>
-                    <a:bodyPr/>
-                    <a:lstStyle/>
-                    <a:p/>
-                  </a:txBody>
-                  <a:tcPr/>
-                </a:tc>
-              </a:tr>
-              <a:tr h="384048">
-                <a:tc>
-                  <a:txBody>
-                    <a:bodyPr/>
-                    <a:lstStyle/>
-                    <a:p>
-                      <a:r>
-                        <a:rPr sz="1050">
-                          <a:solidFill>
-                            <a:srgbClr val="3D5466"/>
-                          </a:solidFill>
-                          <a:latin typeface="Arial"/>
-                        </a:rPr>
-                        <a:t>Frühwarnliste</a:t>
-                      </a:r>
-                    </a:p>
-                  </a:txBody>
-                  <a:tcPr/>
-                </a:tc>
-                <a:tc>
-                  <a:txBody>
-                    <a:bodyPr/>
-                    <a:lstStyle/>
-                    <a:p/>
-                  </a:txBody>
-                  <a:tcPr/>
-                </a:tc>
-                <a:tc>
-                  <a:txBody>
-                    <a:bodyPr/>
-                    <a:lstStyle/>
-                    <a:p/>
-                  </a:txBody>
-                  <a:tcPr/>
-                </a:tc>
-              </a:tr>
-              <a:tr h="384048">
-                <a:tc>
-                  <a:txBody>
-                    <a:bodyPr/>
-                    <a:lstStyle/>
-                    <a:p>
-                      <a:r>
-                        <a:rPr sz="1050">
-                          <a:solidFill>
-                            <a:srgbClr val="3D5466"/>
-                          </a:solidFill>
-                          <a:latin typeface="Arial"/>
-                        </a:rPr>
-                        <a:t>Aktivitäten / Aufgabenverwaltung</a:t>
-                      </a:r>
-                    </a:p>
-                  </a:txBody>
-                  <a:tcPr/>
-                </a:tc>
-                <a:tc>
-                  <a:txBody>
-                    <a:bodyPr/>
-                    <a:lstStyle/>
-                    <a:p/>
-                  </a:txBody>
-                  <a:tcPr/>
-                </a:tc>
-                <a:tc>
-                  <a:txBody>
-                    <a:bodyPr/>
-                    <a:lstStyle/>
-                    <a:p/>
-                  </a:txBody>
-                  <a:tcPr/>
-                </a:tc>
-              </a:tr>
-            </a:tbl>
-          </a:graphicData>
-        </a:graphic>
-      </p:graphicFrame>
-      <p:sp>
-        <p:nvSpPr>
-          <p:cNvPr id="8" name="Rectangle 7"/>
+      <p:sp>
+        <p:nvSpPr>
+          <p:cNvPr id="7" name="TextBox 6"/>
+          <p:cNvSpPr txBox="1"/>
+          <p:nvPr/>
+        </p:nvSpPr>
+        <p:spPr>
+          <a:xfrm>
+            <a:off x="813816" y="502920"/>
+            <a:ext cx="10634472" cy="685800"/>
+          </a:xfrm>
+          <a:prstGeom prst="rect">
+            <a:avLst/>
+          </a:prstGeom>
+          <a:noFill/>
+        </p:spPr>
+        <p:txBody>
+          <a:bodyPr wrap="square">
+            <a:spAutoFit/>
+          </a:bodyPr>
+          <a:lstStyle/>
+          <a:p>
+            <a:pPr algn="l"/>
+            <a:r>
+              <a:rPr sz="2400" b="1" i="0">
+                <a:solidFill>
+                  <a:srgbClr val="1F2C56"/>
+                </a:solidFill>
+                <a:latin typeface="Arial"/>
+              </a:rPr>
+              <a:t>Reflexion und Selbstcheck</a:t>
+            </a:r>
+          </a:p>
+        </p:txBody>
+      </p:sp>
+      <p:sp>
+        <p:nvSpPr>
+          <p:cNvPr id="8" name="TextBox 7"/>
+          <p:cNvSpPr txBox="1"/>
+          <p:nvPr/>
+        </p:nvSpPr>
+        <p:spPr>
+          <a:xfrm>
+            <a:off x="685800" y="1417320"/>
+            <a:ext cx="10817352" cy="4892040"/>
+          </a:xfrm>
+          <a:prstGeom prst="rect">
+            <a:avLst/>
+          </a:prstGeom>
+          <a:noFill/>
+        </p:spPr>
+        <p:txBody>
+          <a:bodyPr wrap="square" anchor="ctr">
+            <a:spAutoFit/>
+          </a:bodyPr>
+          <a:lstStyle/>
+          <a:p>
+            <a:pPr marL="190500" indent="-190500">
+              <a:spcBef>
+                <a:spcPts val="400"/>
+              </a:spcBef>
+              <a:spcAft>
+                <a:spcPts val="200"/>
+              </a:spcAft>
+            </a:pPr>
+            <a:r>
+              <a:rPr sz="1300">
+                <a:solidFill>
+                  <a:srgbClr val="3D5466"/>
+                </a:solidFill>
+                <a:latin typeface="Arial"/>
+              </a:rPr>
+              <a:t>▸  Welcher der drei Workflow-Phasen kostet Sie heute am meisten Zeit?</a:t>
+            </a:r>
+          </a:p>
+          <a:p>
+            <a:pPr marL="190500" indent="-190500">
+              <a:spcBef>
+                <a:spcPts val="400"/>
+              </a:spcBef>
+              <a:spcAft>
+                <a:spcPts val="200"/>
+              </a:spcAft>
+            </a:pPr>
+            <a:r>
+              <a:rPr sz="1300">
+                <a:solidFill>
+                  <a:srgbClr val="3D5466"/>
+                </a:solidFill>
+                <a:latin typeface="Arial"/>
+              </a:rPr>
+              <a:t>▸  Welchen agree-Kernbereich nutzen Sie bislang am wenigsten?</a:t>
+            </a:r>
+          </a:p>
+          <a:p>
+            <a:pPr marL="190500" indent="-190500">
+              <a:spcBef>
+                <a:spcPts val="400"/>
+              </a:spcBef>
+              <a:spcAft>
+                <a:spcPts val="200"/>
+              </a:spcAft>
+            </a:pPr>
+            <a:r>
+              <a:rPr sz="1300">
+                <a:solidFill>
+                  <a:srgbClr val="3D5466"/>
+                </a:solidFill>
+                <a:latin typeface="Arial"/>
+              </a:rPr>
+              <a:t>▸  Welche eine Routine ändern Sie ab morgen, um Zeit fürs Gespräch zu gewinnen?</a:t>
+            </a:r>
+          </a:p>
+        </p:txBody>
+      </p:sp>
+      <p:sp>
+        <p:nvSpPr>
+          <p:cNvPr id="9" name="Rectangle 8"/>
           <p:cNvSpPr/>
           <p:nvPr/>
         </p:nvSpPr>
@@ -6583,7 +6091,7 @@
       </p:sp>
       <p:sp>
         <p:nvSpPr>
-          <p:cNvPr id="9" name="TextBox 8"/>
+          <p:cNvPr id="10" name="TextBox 9"/>
           <p:cNvSpPr txBox="1"/>
           <p:nvPr/>
         </p:nvSpPr>
@@ -6612,621 +6120,6 @@
                 <a:latin typeface="Consolas"/>
               </a:rPr>
               <a:t>FKB Campus  ·  M17</a:t>
-            </a:r>
-          </a:p>
-        </p:txBody>
-      </p:sp>
-      <p:sp>
-        <p:nvSpPr>
-          <p:cNvPr id="10" name="TextBox 9"/>
-          <p:cNvSpPr txBox="1"/>
-          <p:nvPr/>
-        </p:nvSpPr>
-        <p:spPr>
-          <a:xfrm>
-            <a:off x="7176211" y="6583680"/>
-            <a:ext cx="4326940" cy="256032"/>
-          </a:xfrm>
-          <a:prstGeom prst="rect">
-            <a:avLst/>
-          </a:prstGeom>
-          <a:noFill/>
-        </p:spPr>
-        <p:txBody>
-          <a:bodyPr wrap="none">
-            <a:spAutoFit/>
-          </a:bodyPr>
-          <a:lstStyle/>
-          <a:p>
-            <a:pPr algn="r"/>
-            <a:r>
-              <a:rPr sz="700">
-                <a:solidFill>
-                  <a:srgbClr val="A0B4D2"/>
-                </a:solidFill>
-                <a:latin typeface="Consolas"/>
-              </a:rPr>
-              <a:t>Übersicht</a:t>
-            </a:r>
-          </a:p>
-        </p:txBody>
-      </p:sp>
-    </p:spTree>
-  </p:cSld>
-  <p:clrMapOvr>
-    <a:masterClrMapping/>
-  </p:clrMapOvr>
-</p:sld>
-</file>
-
-<file path=ppt/slides/slide14.xml><?xml version="1.0" encoding="utf-8"?>
-<p:sld xmlns:a="http://schemas.openxmlformats.org/drawingml/2006/main" xmlns:p="http://schemas.openxmlformats.org/presentationml/2006/main" xmlns:r="http://schemas.openxmlformats.org/officeDocument/2006/relationships">
-  <p:cSld>
-    <p:spTree>
-      <p:nvGrpSpPr>
-        <p:cNvPr id="1" name=""/>
-        <p:cNvGrpSpPr/>
-        <p:nvPr/>
-      </p:nvGrpSpPr>
-      <p:grpSpPr/>
-      <p:sp>
-        <p:nvSpPr>
-          <p:cNvPr id="2" name="Rectangle 1"/>
-          <p:cNvSpPr/>
-          <p:nvPr/>
-        </p:nvSpPr>
-        <p:spPr>
-          <a:xfrm>
-            <a:off x="0" y="0"/>
-            <a:ext cx="12188952" cy="6858000"/>
-          </a:xfrm>
-          <a:prstGeom prst="rect">
-            <a:avLst/>
-          </a:prstGeom>
-          <a:solidFill>
-            <a:srgbClr val="FFFFFF"/>
-          </a:solidFill>
-          <a:ln>
-            <a:noFill/>
-          </a:ln>
-        </p:spPr>
-        <p:style>
-          <a:lnRef idx="1">
-            <a:schemeClr val="accent1"/>
-          </a:lnRef>
-          <a:fillRef idx="3">
-            <a:schemeClr val="accent1"/>
-          </a:fillRef>
-          <a:effectRef idx="2">
-            <a:schemeClr val="accent1"/>
-          </a:effectRef>
-          <a:fontRef idx="minor">
-            <a:schemeClr val="lt1"/>
-          </a:fontRef>
-        </p:style>
-        <p:txBody>
-          <a:bodyPr rtlCol="0" anchor="ctr"/>
-          <a:lstStyle/>
-          <a:p>
-            <a:pPr algn="ctr"/>
-          </a:p>
-        </p:txBody>
-      </p:sp>
-      <p:sp>
-        <p:nvSpPr>
-          <p:cNvPr id="3" name="Rectangle 2"/>
-          <p:cNvSpPr/>
-          <p:nvPr/>
-        </p:nvSpPr>
-        <p:spPr>
-          <a:xfrm>
-            <a:off x="0" y="0"/>
-            <a:ext cx="12188952" cy="50292"/>
-          </a:xfrm>
-          <a:prstGeom prst="rect">
-            <a:avLst/>
-          </a:prstGeom>
-          <a:solidFill>
-            <a:srgbClr val="1F2C56"/>
-          </a:solidFill>
-          <a:ln>
-            <a:noFill/>
-          </a:ln>
-        </p:spPr>
-        <p:style>
-          <a:lnRef idx="1">
-            <a:schemeClr val="accent1"/>
-          </a:lnRef>
-          <a:fillRef idx="3">
-            <a:schemeClr val="accent1"/>
-          </a:fillRef>
-          <a:effectRef idx="2">
-            <a:schemeClr val="accent1"/>
-          </a:effectRef>
-          <a:fontRef idx="minor">
-            <a:schemeClr val="lt1"/>
-          </a:fontRef>
-        </p:style>
-        <p:txBody>
-          <a:bodyPr rtlCol="0" anchor="ctr"/>
-          <a:lstStyle/>
-          <a:p>
-            <a:pPr algn="ctr"/>
-          </a:p>
-        </p:txBody>
-      </p:sp>
-      <p:sp>
-        <p:nvSpPr>
-          <p:cNvPr id="4" name="TextBox 3"/>
-          <p:cNvSpPr txBox="1"/>
-          <p:nvPr/>
-        </p:nvSpPr>
-        <p:spPr>
-          <a:xfrm>
-            <a:off x="685800" y="109728"/>
-            <a:ext cx="10817352" cy="228600"/>
-          </a:xfrm>
-          <a:prstGeom prst="rect">
-            <a:avLst/>
-          </a:prstGeom>
-          <a:noFill/>
-        </p:spPr>
-        <p:txBody>
-          <a:bodyPr wrap="none">
-            <a:spAutoFit/>
-          </a:bodyPr>
-          <a:lstStyle/>
-          <a:p>
-            <a:pPr algn="l"/>
-            <a:r>
-              <a:rPr sz="750">
-                <a:solidFill>
-                  <a:srgbClr val="78808C"/>
-                </a:solidFill>
-                <a:latin typeface="Consolas"/>
-              </a:rPr>
-              <a:t>M17  ·  ÜBERSICHT</a:t>
-            </a:r>
-          </a:p>
-        </p:txBody>
-      </p:sp>
-      <p:sp>
-        <p:nvSpPr>
-          <p:cNvPr id="5" name="TextBox 4"/>
-          <p:cNvSpPr txBox="1"/>
-          <p:nvPr/>
-        </p:nvSpPr>
-        <p:spPr>
-          <a:xfrm>
-            <a:off x="685800" y="502920"/>
-            <a:ext cx="10817352" cy="594360"/>
-          </a:xfrm>
-          <a:prstGeom prst="rect">
-            <a:avLst/>
-          </a:prstGeom>
-          <a:noFill/>
-        </p:spPr>
-        <p:txBody>
-          <a:bodyPr wrap="square">
-            <a:spAutoFit/>
-          </a:bodyPr>
-          <a:lstStyle/>
-          <a:p>
-            <a:pPr algn="l"/>
-            <a:r>
-              <a:rPr sz="2000" b="1" i="0">
-                <a:solidFill>
-                  <a:srgbClr val="1F2C56"/>
-                </a:solidFill>
-                <a:latin typeface="Arial"/>
-              </a:rPr>
-              <a:t>AB-2: Workflow-Optimierungsplan</a:t>
-            </a:r>
-          </a:p>
-        </p:txBody>
-      </p:sp>
-      <p:sp>
-        <p:nvSpPr>
-          <p:cNvPr id="6" name="Rectangle 5"/>
-          <p:cNvSpPr/>
-          <p:nvPr/>
-        </p:nvSpPr>
-        <p:spPr>
-          <a:xfrm>
-            <a:off x="685800" y="1143000"/>
-            <a:ext cx="10817352" cy="25400"/>
-          </a:xfrm>
-          <a:prstGeom prst="rect">
-            <a:avLst/>
-          </a:prstGeom>
-          <a:solidFill>
-            <a:srgbClr val="D9C089"/>
-          </a:solidFill>
-          <a:ln>
-            <a:noFill/>
-          </a:ln>
-        </p:spPr>
-        <p:style>
-          <a:lnRef idx="1">
-            <a:schemeClr val="accent1"/>
-          </a:lnRef>
-          <a:fillRef idx="3">
-            <a:schemeClr val="accent1"/>
-          </a:fillRef>
-          <a:effectRef idx="2">
-            <a:schemeClr val="accent1"/>
-          </a:effectRef>
-          <a:fontRef idx="minor">
-            <a:schemeClr val="lt1"/>
-          </a:fontRef>
-        </p:style>
-        <p:txBody>
-          <a:bodyPr rtlCol="0" anchor="ctr"/>
-          <a:lstStyle/>
-          <a:p>
-            <a:pPr algn="ctr"/>
-          </a:p>
-        </p:txBody>
-      </p:sp>
-      <p:graphicFrame>
-        <p:nvGraphicFramePr>
-          <p:cNvPr id="7" name="Table 6"/>
-          <p:cNvGraphicFramePr>
-            <a:graphicFrameLocks noGrp="1"/>
-          </p:cNvGraphicFramePr>
-          <p:nvPr/>
-        </p:nvGraphicFramePr>
-        <p:xfrm>
-          <a:off x="685800" y="1417320"/>
-          <a:ext cx="10817352" cy="1536192"/>
-        </p:xfrm>
-        <a:graphic>
-          <a:graphicData uri="http://schemas.openxmlformats.org/drawingml/2006/table">
-            <a:tbl>
-              <a:tblPr firstRow="1" bandRow="1">
-                <a:tableStyleId>{5C22544A-7EE6-4342-B048-85BDC9FD1C3A}</a:tableStyleId>
-              </a:tblPr>
-              <a:tblGrid>
-                <a:gridCol w="2704338"/>
-                <a:gridCol w="2704338"/>
-                <a:gridCol w="2704338"/>
-                <a:gridCol w="2704338"/>
-              </a:tblGrid>
-              <a:tr h="384048">
-                <a:tc>
-                  <a:txBody>
-                    <a:bodyPr/>
-                    <a:lstStyle/>
-                    <a:p>
-                      <a:r>
-                        <a:rPr sz="1100" b="1">
-                          <a:solidFill>
-                            <a:srgbClr val="FFFFFF"/>
-                          </a:solidFill>
-                          <a:latin typeface="Arial"/>
-                        </a:rPr>
-                        <a:t>Phase</a:t>
-                      </a:r>
-                    </a:p>
-                  </a:txBody>
-                  <a:tcPr>
-                    <a:solidFill>
-                      <a:srgbClr val="1F2C56"/>
-                    </a:solidFill>
-                  </a:tcPr>
-                </a:tc>
-                <a:tc>
-                  <a:txBody>
-                    <a:bodyPr/>
-                    <a:lstStyle/>
-                    <a:p>
-                      <a:r>
-                        <a:rPr sz="1100" b="1">
-                          <a:solidFill>
-                            <a:srgbClr val="FFFFFF"/>
-                          </a:solidFill>
-                          <a:latin typeface="Arial"/>
-                        </a:rPr>
-                        <a:t>Aktuell</a:t>
-                      </a:r>
-                    </a:p>
-                  </a:txBody>
-                  <a:tcPr>
-                    <a:solidFill>
-                      <a:srgbClr val="1F2C56"/>
-                    </a:solidFill>
-                  </a:tcPr>
-                </a:tc>
-                <a:tc>
-                  <a:txBody>
-                    <a:bodyPr/>
-                    <a:lstStyle/>
-                    <a:p>
-                      <a:r>
-                        <a:rPr sz="1100" b="1">
-                          <a:solidFill>
-                            <a:srgbClr val="FFFFFF"/>
-                          </a:solidFill>
-                          <a:latin typeface="Arial"/>
-                        </a:rPr>
-                        <a:t>Ziel nach Optimierung</a:t>
-                      </a:r>
-                    </a:p>
-                  </a:txBody>
-                  <a:tcPr>
-                    <a:solidFill>
-                      <a:srgbClr val="1F2C56"/>
-                    </a:solidFill>
-                  </a:tcPr>
-                </a:tc>
-                <a:tc>
-                  <a:txBody>
-                    <a:bodyPr/>
-                    <a:lstStyle/>
-                    <a:p>
-                      <a:r>
-                        <a:rPr sz="1100" b="1">
-                          <a:solidFill>
-                            <a:srgbClr val="FFFFFF"/>
-                          </a:solidFill>
-                          <a:latin typeface="Arial"/>
-                        </a:rPr>
-                        <a:t>Maßnahme</a:t>
-                      </a:r>
-                    </a:p>
-                  </a:txBody>
-                  <a:tcPr>
-                    <a:solidFill>
-                      <a:srgbClr val="1F2C56"/>
-                    </a:solidFill>
-                  </a:tcPr>
-                </a:tc>
-              </a:tr>
-              <a:tr h="384048">
-                <a:tc>
-                  <a:txBody>
-                    <a:bodyPr/>
-                    <a:lstStyle/>
-                    <a:p>
-                      <a:r>
-                        <a:rPr sz="1050">
-                          <a:solidFill>
-                            <a:srgbClr val="3D5466"/>
-                          </a:solidFill>
-                          <a:latin typeface="Arial"/>
-                        </a:rPr>
-                        <a:t>Vorbereitung</a:t>
-                      </a:r>
-                    </a:p>
-                  </a:txBody>
-                  <a:tcPr/>
-                </a:tc>
-                <a:tc>
-                  <a:txBody>
-                    <a:bodyPr/>
-                    <a:lstStyle/>
-                    <a:p/>
-                  </a:txBody>
-                  <a:tcPr/>
-                </a:tc>
-                <a:tc>
-                  <a:txBody>
-                    <a:bodyPr/>
-                    <a:lstStyle/>
-                    <a:p/>
-                  </a:txBody>
-                  <a:tcPr/>
-                </a:tc>
-                <a:tc>
-                  <a:txBody>
-                    <a:bodyPr/>
-                    <a:lstStyle/>
-                    <a:p/>
-                  </a:txBody>
-                  <a:tcPr/>
-                </a:tc>
-              </a:tr>
-              <a:tr h="384048">
-                <a:tc>
-                  <a:txBody>
-                    <a:bodyPr/>
-                    <a:lstStyle/>
-                    <a:p>
-                      <a:r>
-                        <a:rPr sz="1050">
-                          <a:solidFill>
-                            <a:srgbClr val="3D5466"/>
-                          </a:solidFill>
-                          <a:latin typeface="Arial"/>
-                        </a:rPr>
-                        <a:t>Nachbereitung</a:t>
-                      </a:r>
-                    </a:p>
-                  </a:txBody>
-                  <a:tcPr/>
-                </a:tc>
-                <a:tc>
-                  <a:txBody>
-                    <a:bodyPr/>
-                    <a:lstStyle/>
-                    <a:p/>
-                  </a:txBody>
-                  <a:tcPr/>
-                </a:tc>
-                <a:tc>
-                  <a:txBody>
-                    <a:bodyPr/>
-                    <a:lstStyle/>
-                    <a:p/>
-                  </a:txBody>
-                  <a:tcPr/>
-                </a:tc>
-                <a:tc>
-                  <a:txBody>
-                    <a:bodyPr/>
-                    <a:lstStyle/>
-                    <a:p/>
-                  </a:txBody>
-                  <a:tcPr/>
-                </a:tc>
-              </a:tr>
-              <a:tr h="384048">
-                <a:tc>
-                  <a:txBody>
-                    <a:bodyPr/>
-                    <a:lstStyle/>
-                    <a:p>
-                      <a:r>
-                        <a:rPr sz="1050">
-                          <a:solidFill>
-                            <a:srgbClr val="3D5466"/>
-                          </a:solidFill>
-                          <a:latin typeface="Arial"/>
-                        </a:rPr>
-                        <a:t>Reporting-Routine</a:t>
-                      </a:r>
-                    </a:p>
-                  </a:txBody>
-                  <a:tcPr/>
-                </a:tc>
-                <a:tc>
-                  <a:txBody>
-                    <a:bodyPr/>
-                    <a:lstStyle/>
-                    <a:p/>
-                  </a:txBody>
-                  <a:tcPr/>
-                </a:tc>
-                <a:tc>
-                  <a:txBody>
-                    <a:bodyPr/>
-                    <a:lstStyle/>
-                    <a:p/>
-                  </a:txBody>
-                  <a:tcPr/>
-                </a:tc>
-                <a:tc>
-                  <a:txBody>
-                    <a:bodyPr/>
-                    <a:lstStyle/>
-                    <a:p/>
-                  </a:txBody>
-                  <a:tcPr/>
-                </a:tc>
-              </a:tr>
-            </a:tbl>
-          </a:graphicData>
-        </a:graphic>
-      </p:graphicFrame>
-      <p:sp>
-        <p:nvSpPr>
-          <p:cNvPr id="8" name="Rectangle 7"/>
-          <p:cNvSpPr/>
-          <p:nvPr/>
-        </p:nvSpPr>
-        <p:spPr>
-          <a:xfrm>
-            <a:off x="0" y="6510528"/>
-            <a:ext cx="12188952" cy="347472"/>
-          </a:xfrm>
-          <a:prstGeom prst="rect">
-            <a:avLst/>
-          </a:prstGeom>
-          <a:solidFill>
-            <a:srgbClr val="0A1937"/>
-          </a:solidFill>
-          <a:ln>
-            <a:noFill/>
-          </a:ln>
-        </p:spPr>
-        <p:style>
-          <a:lnRef idx="1">
-            <a:schemeClr val="accent1"/>
-          </a:lnRef>
-          <a:fillRef idx="3">
-            <a:schemeClr val="accent1"/>
-          </a:fillRef>
-          <a:effectRef idx="2">
-            <a:schemeClr val="accent1"/>
-          </a:effectRef>
-          <a:fontRef idx="minor">
-            <a:schemeClr val="lt1"/>
-          </a:fontRef>
-        </p:style>
-        <p:txBody>
-          <a:bodyPr rtlCol="0" anchor="ctr"/>
-          <a:lstStyle/>
-          <a:p>
-            <a:pPr algn="ctr"/>
-          </a:p>
-        </p:txBody>
-      </p:sp>
-      <p:sp>
-        <p:nvSpPr>
-          <p:cNvPr id="9" name="TextBox 8"/>
-          <p:cNvSpPr txBox="1"/>
-          <p:nvPr/>
-        </p:nvSpPr>
-        <p:spPr>
-          <a:xfrm>
-            <a:off x="685800" y="6583680"/>
-            <a:ext cx="6490411" cy="256032"/>
-          </a:xfrm>
-          <a:prstGeom prst="rect">
-            <a:avLst/>
-          </a:prstGeom>
-          <a:noFill/>
-        </p:spPr>
-        <p:txBody>
-          <a:bodyPr wrap="none">
-            <a:spAutoFit/>
-          </a:bodyPr>
-          <a:lstStyle/>
-          <a:p>
-            <a:pPr algn="l"/>
-            <a:r>
-              <a:rPr sz="700">
-                <a:solidFill>
-                  <a:srgbClr val="A0B4D2"/>
-                </a:solidFill>
-                <a:latin typeface="Consolas"/>
-              </a:rPr>
-              <a:t>FKB Campus  ·  M17</a:t>
-            </a:r>
-          </a:p>
-        </p:txBody>
-      </p:sp>
-      <p:sp>
-        <p:nvSpPr>
-          <p:cNvPr id="10" name="TextBox 9"/>
-          <p:cNvSpPr txBox="1"/>
-          <p:nvPr/>
-        </p:nvSpPr>
-        <p:spPr>
-          <a:xfrm>
-            <a:off x="7176211" y="6583680"/>
-            <a:ext cx="4326940" cy="256032"/>
-          </a:xfrm>
-          <a:prstGeom prst="rect">
-            <a:avLst/>
-          </a:prstGeom>
-          <a:noFill/>
-        </p:spPr>
-        <p:txBody>
-          <a:bodyPr wrap="none">
-            <a:spAutoFit/>
-          </a:bodyPr>
-          <a:lstStyle/>
-          <a:p>
-            <a:pPr algn="r"/>
-            <a:r>
-              <a:rPr sz="700">
-                <a:solidFill>
-                  <a:srgbClr val="A0B4D2"/>
-                </a:solidFill>
-                <a:latin typeface="Consolas"/>
-              </a:rPr>
-              <a:t>Übersicht</a:t>
             </a:r>
           </a:p>
         </p:txBody>
@@ -9018,7 +7911,7 @@
                 </a:solidFill>
                 <a:latin typeface="Arial"/>
               </a:rPr>
-              <a:t>Die häufigsten agree-Fehler im Firmenkundenalltag</a:t>
+              <a:t>Das System soll dir Zeit fürs Gespräch schenken</a:t>
             </a:r>
           </a:p>
         </p:txBody>
@@ -9044,6 +7937,25 @@
             <a:spAutoFit/>
           </a:bodyPr>
           <a:lstStyle/>
+          <a:p>
+            <a:pPr marL="177800" indent="-177800">
+              <a:spcBef>
+                <a:spcPts val="600"/>
+              </a:spcBef>
+              <a:spcAft>
+                <a:spcPts val="200"/>
+              </a:spcAft>
+            </a:pPr>
+            <a:r>
+              <a:rPr sz="1200" i="1">
+                <a:solidFill>
+                  <a:srgbClr val="3D5466"/>
+                </a:solidFill>
+                <a:latin typeface="Arial"/>
+              </a:rPr>
+              <a:t>→  Das System soll dir Zeit fürs Gespräch schenken, nicht sie nehmen.</a:t>
+            </a:r>
+          </a:p>
           <a:p>
             <a:pPr marL="190500" indent="-190500">
               <a:spcBef>
@@ -9060,7 +7972,7 @@
                 </a:solidFill>
                 <a:latin typeface="Arial"/>
               </a:rPr>
-              <a:t>▸  ## 4.2 Effizienter Gesprächsworkflow: Vor – Während – Nach</a:t>
+              <a:t>▸  Wer agree für Vorbereitung und Dokumentation beherrscht, gewinnt Minuten je Termin zurück.</a:t>
             </a:r>
           </a:p>
           <a:p>
@@ -9079,7 +7991,7 @@
                 </a:solidFill>
                 <a:latin typeface="Arial"/>
               </a:rPr>
-              <a:t>▸  Der größte Effizienzgewinn entsteht nicht aus einzelnen Funktionen, sondern aus einem konsistenten Workflow, der agree konsequent in alle drei Gesprächsphasen einbindet.</a:t>
+              <a:t>▸  Diese Minuten gehören dem Kunden – nicht der Maske.</a:t>
             </a:r>
           </a:p>
         </p:txBody>
@@ -9195,7 +8107,7 @@
             <a:avLst/>
           </a:prstGeom>
           <a:solidFill>
-            <a:srgbClr val="FFFFFF"/>
+            <a:srgbClr val="EDEDF3"/>
           </a:solidFill>
           <a:ln>
             <a:noFill/>
@@ -9296,43 +8208,51 @@
                 </a:solidFill>
                 <a:latin typeface="Consolas"/>
               </a:rPr>
-              <a:t>M17  ·  SCHAUBILD</a:t>
-            </a:r>
-          </a:p>
-        </p:txBody>
-      </p:sp>
-      <p:sp>
-        <p:nvSpPr>
-          <p:cNvPr id="5" name="TextBox 4"/>
-          <p:cNvSpPr txBox="1"/>
-          <p:nvPr/>
-        </p:nvSpPr>
-        <p:spPr>
-          <a:xfrm>
-            <a:off x="685800" y="502920"/>
-            <a:ext cx="10817352" cy="594360"/>
-          </a:xfrm>
-          <a:prstGeom prst="rect">
-            <a:avLst/>
-          </a:prstGeom>
-          <a:noFill/>
-        </p:spPr>
-        <p:txBody>
-          <a:bodyPr wrap="square">
-            <a:spAutoFit/>
-          </a:bodyPr>
-          <a:lstStyle/>
-          <a:p>
-            <a:pPr algn="l"/>
-            <a:r>
-              <a:rPr sz="2000" b="1" i="0">
-                <a:solidFill>
-                  <a:srgbClr val="1F2C56"/>
-                </a:solidFill>
-                <a:latin typeface="Arial"/>
-              </a:rPr>
-              <a:t>agree21 Kernbereiche für Firmenkundenberater</a:t>
-            </a:r>
+              <a:t>M17  ·  INHALT</a:t>
+            </a:r>
+          </a:p>
+        </p:txBody>
+      </p:sp>
+      <p:sp>
+        <p:nvSpPr>
+          <p:cNvPr id="5" name="Rectangle 4"/>
+          <p:cNvSpPr/>
+          <p:nvPr/>
+        </p:nvSpPr>
+        <p:spPr>
+          <a:xfrm>
+            <a:off x="0" y="1234440"/>
+            <a:ext cx="12188952" cy="12700"/>
+          </a:xfrm>
+          <a:prstGeom prst="rect">
+            <a:avLst/>
+          </a:prstGeom>
+          <a:solidFill>
+            <a:srgbClr val="D8DFE4"/>
+          </a:solidFill>
+          <a:ln>
+            <a:noFill/>
+          </a:ln>
+        </p:spPr>
+        <p:style>
+          <a:lnRef idx="1">
+            <a:schemeClr val="accent1"/>
+          </a:lnRef>
+          <a:fillRef idx="3">
+            <a:schemeClr val="accent1"/>
+          </a:fillRef>
+          <a:effectRef idx="2">
+            <a:schemeClr val="accent1"/>
+          </a:effectRef>
+          <a:fontRef idx="minor">
+            <a:schemeClr val="lt1"/>
+          </a:fontRef>
+        </p:style>
+        <p:txBody>
+          <a:bodyPr rtlCol="0" anchor="ctr"/>
+          <a:lstStyle/>
+          <a:p>
+            <a:pPr algn="ctr"/>
           </a:p>
         </p:txBody>
       </p:sp>
@@ -9344,8 +8264,8 @@
         </p:nvSpPr>
         <p:spPr>
           <a:xfrm>
-            <a:off x="685800" y="1143000"/>
-            <a:ext cx="10817352" cy="25400"/>
+            <a:off x="685800" y="502920"/>
+            <a:ext cx="36576" cy="658368"/>
           </a:xfrm>
           <a:prstGeom prst="rect">
             <a:avLst/>
@@ -9379,33 +8299,124 @@
           </a:p>
         </p:txBody>
       </p:sp>
-      <p:pic>
-        <p:nvPicPr>
-          <p:cNvPr id="7" name="Picture 6" descr="image.png"/>
-          <p:cNvPicPr>
-            <a:picLocks noChangeAspect="1"/>
-          </p:cNvPicPr>
-          <p:nvPr/>
-        </p:nvPicPr>
-        <p:blipFill>
-          <a:blip r:embed="rId2"/>
-          <a:stretch>
-            <a:fillRect/>
-          </a:stretch>
-        </p:blipFill>
-        <p:spPr>
-          <a:xfrm>
-            <a:off x="2163921" y="1325880"/>
-            <a:ext cx="7861110" cy="4937760"/>
-          </a:xfrm>
-          <a:prstGeom prst="rect">
-            <a:avLst/>
-          </a:prstGeom>
-        </p:spPr>
-      </p:pic>
-      <p:sp>
-        <p:nvSpPr>
-          <p:cNvPr id="8" name="Rectangle 7"/>
+      <p:sp>
+        <p:nvSpPr>
+          <p:cNvPr id="7" name="TextBox 6"/>
+          <p:cNvSpPr txBox="1"/>
+          <p:nvPr/>
+        </p:nvSpPr>
+        <p:spPr>
+          <a:xfrm>
+            <a:off x="813816" y="502920"/>
+            <a:ext cx="10634472" cy="685800"/>
+          </a:xfrm>
+          <a:prstGeom prst="rect">
+            <a:avLst/>
+          </a:prstGeom>
+          <a:noFill/>
+        </p:spPr>
+        <p:txBody>
+          <a:bodyPr wrap="square">
+            <a:spAutoFit/>
+          </a:bodyPr>
+          <a:lstStyle/>
+          <a:p>
+            <a:pPr algn="l"/>
+            <a:r>
+              <a:rPr sz="2400" b="1" i="0">
+                <a:solidFill>
+                  <a:srgbClr val="1F2C56"/>
+                </a:solidFill>
+                <a:latin typeface="Arial"/>
+              </a:rPr>
+              <a:t>Fünf Kernbereiche – und die häufigsten Fehler</a:t>
+            </a:r>
+          </a:p>
+        </p:txBody>
+      </p:sp>
+      <p:sp>
+        <p:nvSpPr>
+          <p:cNvPr id="8" name="TextBox 7"/>
+          <p:cNvSpPr txBox="1"/>
+          <p:nvPr/>
+        </p:nvSpPr>
+        <p:spPr>
+          <a:xfrm>
+            <a:off x="685800" y="1417320"/>
+            <a:ext cx="10817352" cy="4892040"/>
+          </a:xfrm>
+          <a:prstGeom prst="rect">
+            <a:avLst/>
+          </a:prstGeom>
+          <a:noFill/>
+        </p:spPr>
+        <p:txBody>
+          <a:bodyPr wrap="square" anchor="ctr">
+            <a:spAutoFit/>
+          </a:bodyPr>
+          <a:lstStyle/>
+          <a:p>
+            <a:pPr marL="177800" indent="-177800">
+              <a:spcBef>
+                <a:spcPts val="600"/>
+              </a:spcBef>
+              <a:spcAft>
+                <a:spcPts val="200"/>
+              </a:spcAft>
+            </a:pPr>
+            <a:r>
+              <a:rPr sz="1200" i="1">
+                <a:solidFill>
+                  <a:srgbClr val="3D5466"/>
+                </a:solidFill>
+                <a:latin typeface="Arial"/>
+              </a:rPr>
+              <a:t>→  Wer die fünf Kernbereiche von agree kennt, arbeitet mit dem System statt gegen es.</a:t>
+            </a:r>
+          </a:p>
+          <a:p>
+            <a:pPr marL="190500" indent="-190500">
+              <a:spcBef>
+                <a:spcPts val="400"/>
+              </a:spcBef>
+              <a:spcAft>
+                <a:spcPts val="200"/>
+              </a:spcAft>
+            </a:pPr>
+            <a:r>
+              <a:rPr sz="1300">
+                <a:solidFill>
+                  <a:srgbClr val="3D5466"/>
+                </a:solidFill>
+                <a:latin typeface="Arial"/>
+              </a:rPr>
+              <a:t>▸  Kundenstamm, Engagement, Vorgänge, UnternehmerDialog, Reporting.</a:t>
+            </a:r>
+          </a:p>
+          <a:p>
+            <a:pPr marL="190500" indent="-190500">
+              <a:spcBef>
+                <a:spcPts val="400"/>
+              </a:spcBef>
+              <a:spcAft>
+                <a:spcPts val="200"/>
+              </a:spcAft>
+            </a:pPr>
+            <a:r>
+              <a:rPr sz="1300">
+                <a:solidFill>
+                  <a:srgbClr val="3D5466"/>
+                </a:solidFill>
+                <a:latin typeface="Arial"/>
+              </a:rPr>
+              <a:t>▸  Die häufigsten Fehler kosten Zeit: Doppelerfassung, verstreute Notizen, ungenutzte Vorlagen.</a:t>
+            </a:r>
+          </a:p>
+        </p:txBody>
+      </p:sp>
+      <p:sp>
+        <p:nvSpPr>
+          <p:cNvPr id="9" name="Rectangle 8"/>
           <p:cNvSpPr/>
           <p:nvPr/>
         </p:nvSpPr>
@@ -9448,7 +8459,7 @@
       </p:sp>
       <p:sp>
         <p:nvSpPr>
-          <p:cNvPr id="9" name="TextBox 8"/>
+          <p:cNvPr id="10" name="TextBox 9"/>
           <p:cNvSpPr txBox="1"/>
           <p:nvPr/>
         </p:nvSpPr>
@@ -9477,41 +8488,6 @@
                 <a:latin typeface="Consolas"/>
               </a:rPr>
               <a:t>FKB Campus  ·  M17</a:t>
-            </a:r>
-          </a:p>
-        </p:txBody>
-      </p:sp>
-      <p:sp>
-        <p:nvSpPr>
-          <p:cNvPr id="10" name="TextBox 9"/>
-          <p:cNvSpPr txBox="1"/>
-          <p:nvPr/>
-        </p:nvSpPr>
-        <p:spPr>
-          <a:xfrm>
-            <a:off x="7176211" y="6583680"/>
-            <a:ext cx="4326940" cy="256032"/>
-          </a:xfrm>
-          <a:prstGeom prst="rect">
-            <a:avLst/>
-          </a:prstGeom>
-          <a:noFill/>
-        </p:spPr>
-        <p:txBody>
-          <a:bodyPr wrap="none">
-            <a:spAutoFit/>
-          </a:bodyPr>
-          <a:lstStyle/>
-          <a:p>
-            <a:pPr algn="r"/>
-            <a:r>
-              <a:rPr sz="700">
-                <a:solidFill>
-                  <a:srgbClr val="A0B4D2"/>
-                </a:solidFill>
-                <a:latin typeface="Consolas"/>
-              </a:rPr>
-              <a:t>Schaubild</a:t>
             </a:r>
           </a:p>
         </p:txBody>
@@ -9549,7 +8525,7 @@
             <a:avLst/>
           </a:prstGeom>
           <a:solidFill>
-            <a:srgbClr val="EDEDF3"/>
+            <a:srgbClr val="FFFFFF"/>
           </a:solidFill>
           <a:ln>
             <a:noFill/>
@@ -9650,51 +8626,43 @@
                 </a:solidFill>
                 <a:latin typeface="Consolas"/>
               </a:rPr>
-              <a:t>M17  ·  INHALT</a:t>
-            </a:r>
-          </a:p>
-        </p:txBody>
-      </p:sp>
-      <p:sp>
-        <p:nvSpPr>
-          <p:cNvPr id="5" name="Rectangle 4"/>
-          <p:cNvSpPr/>
-          <p:nvPr/>
-        </p:nvSpPr>
-        <p:spPr>
-          <a:xfrm>
-            <a:off x="0" y="1234440"/>
-            <a:ext cx="12188952" cy="12700"/>
-          </a:xfrm>
-          <a:prstGeom prst="rect">
-            <a:avLst/>
-          </a:prstGeom>
-          <a:solidFill>
-            <a:srgbClr val="D8DFE4"/>
-          </a:solidFill>
-          <a:ln>
-            <a:noFill/>
-          </a:ln>
-        </p:spPr>
-        <p:style>
-          <a:lnRef idx="1">
-            <a:schemeClr val="accent1"/>
-          </a:lnRef>
-          <a:fillRef idx="3">
-            <a:schemeClr val="accent1"/>
-          </a:fillRef>
-          <a:effectRef idx="2">
-            <a:schemeClr val="accent1"/>
-          </a:effectRef>
-          <a:fontRef idx="minor">
-            <a:schemeClr val="lt1"/>
-          </a:fontRef>
-        </p:style>
-        <p:txBody>
-          <a:bodyPr rtlCol="0" anchor="ctr"/>
-          <a:lstStyle/>
-          <a:p>
-            <a:pPr algn="ctr"/>
+              <a:t>M17  ·  SCHAUBILD</a:t>
+            </a:r>
+          </a:p>
+        </p:txBody>
+      </p:sp>
+      <p:sp>
+        <p:nvSpPr>
+          <p:cNvPr id="5" name="TextBox 4"/>
+          <p:cNvSpPr txBox="1"/>
+          <p:nvPr/>
+        </p:nvSpPr>
+        <p:spPr>
+          <a:xfrm>
+            <a:off x="685800" y="502920"/>
+            <a:ext cx="10817352" cy="594360"/>
+          </a:xfrm>
+          <a:prstGeom prst="rect">
+            <a:avLst/>
+          </a:prstGeom>
+          <a:noFill/>
+        </p:spPr>
+        <p:txBody>
+          <a:bodyPr wrap="square">
+            <a:spAutoFit/>
+          </a:bodyPr>
+          <a:lstStyle/>
+          <a:p>
+            <a:pPr algn="l"/>
+            <a:r>
+              <a:rPr sz="2000" b="1" i="0">
+                <a:solidFill>
+                  <a:srgbClr val="1F2C56"/>
+                </a:solidFill>
+                <a:latin typeface="Arial"/>
+              </a:rPr>
+              <a:t>Die agree-Kernbereiche für Firmenkundenberater</a:t>
+            </a:r>
           </a:p>
         </p:txBody>
       </p:sp>
@@ -9706,8 +8674,8 @@
         </p:nvSpPr>
         <p:spPr>
           <a:xfrm>
-            <a:off x="685800" y="502920"/>
-            <a:ext cx="36576" cy="658368"/>
+            <a:off x="685800" y="1143000"/>
+            <a:ext cx="10817352" cy="25400"/>
           </a:xfrm>
           <a:prstGeom prst="rect">
             <a:avLst/>
@@ -9741,105 +8709,33 @@
           </a:p>
         </p:txBody>
       </p:sp>
-      <p:sp>
-        <p:nvSpPr>
-          <p:cNvPr id="7" name="TextBox 6"/>
-          <p:cNvSpPr txBox="1"/>
-          <p:nvPr/>
-        </p:nvSpPr>
-        <p:spPr>
-          <a:xfrm>
-            <a:off x="813816" y="502920"/>
-            <a:ext cx="10634472" cy="685800"/>
-          </a:xfrm>
-          <a:prstGeom prst="rect">
-            <a:avLst/>
-          </a:prstGeom>
-          <a:noFill/>
-        </p:spPr>
-        <p:txBody>
-          <a:bodyPr wrap="square">
-            <a:spAutoFit/>
-          </a:bodyPr>
-          <a:lstStyle/>
-          <a:p>
-            <a:pPr algn="l"/>
-            <a:r>
-              <a:rPr sz="2400" b="1" i="0">
-                <a:solidFill>
-                  <a:srgbClr val="1F2C56"/>
-                </a:solidFill>
-                <a:latin typeface="Arial"/>
-              </a:rPr>
-              <a:t>Phase 1: Vorbereitung (15–20 Minuten statt 45–60 Minuten)</a:t>
-            </a:r>
-          </a:p>
-        </p:txBody>
-      </p:sp>
-      <p:sp>
-        <p:nvSpPr>
-          <p:cNvPr id="8" name="TextBox 7"/>
-          <p:cNvSpPr txBox="1"/>
-          <p:nvPr/>
-        </p:nvSpPr>
-        <p:spPr>
-          <a:xfrm>
-            <a:off x="685800" y="1417320"/>
-            <a:ext cx="10817352" cy="4892040"/>
-          </a:xfrm>
-          <a:prstGeom prst="rect">
-            <a:avLst/>
-          </a:prstGeom>
-          <a:noFill/>
-        </p:spPr>
-        <p:txBody>
-          <a:bodyPr wrap="square" anchor="ctr">
-            <a:spAutoFit/>
-          </a:bodyPr>
-          <a:lstStyle/>
-          <a:p>
-            <a:pPr marL="190500" indent="-190500">
-              <a:spcBef>
-                <a:spcPts val="400"/>
-              </a:spcBef>
-              <a:spcAft>
-                <a:spcPts val="200"/>
-              </a:spcAft>
-            </a:pPr>
-            <a:r>
-              <a:rPr sz="1300">
-                <a:solidFill>
-                  <a:srgbClr val="3D5466"/>
-                </a:solidFill>
-                <a:latin typeface="Arial"/>
-              </a:rPr>
-              <a:t>▸  agree-Checkliste Jahresgespräch:</a:t>
-            </a:r>
-          </a:p>
-          <a:p>
-            <a:pPr marL="190500" indent="-190500">
-              <a:spcBef>
-                <a:spcPts val="400"/>
-              </a:spcBef>
-              <a:spcAft>
-                <a:spcPts val="200"/>
-              </a:spcAft>
-            </a:pPr>
-            <a:r>
-              <a:rPr sz="1300">
-                <a:solidFill>
-                  <a:srgbClr val="3D5466"/>
-                </a:solidFill>
-                <a:latin typeface="Arial"/>
-              </a:rPr>
-              <a:t>▸  Ergebnis: Sie gehen mit einem konkreten Bild in das Gespräch – statt im Gespräch zu blättern.</a:t>
-            </a:r>
-          </a:p>
-        </p:txBody>
-      </p:sp>
-      <p:sp>
-        <p:nvSpPr>
-          <p:cNvPr id="9" name="Rectangle 8"/>
+      <p:pic>
+        <p:nvPicPr>
+          <p:cNvPr id="7" name="Picture 6" descr="image.png"/>
+          <p:cNvPicPr>
+            <a:picLocks noChangeAspect="1"/>
+          </p:cNvPicPr>
+          <p:nvPr/>
+        </p:nvPicPr>
+        <p:blipFill>
+          <a:blip r:embed="rId2"/>
+          <a:stretch>
+            <a:fillRect/>
+          </a:stretch>
+        </p:blipFill>
+        <p:spPr>
+          <a:xfrm>
+            <a:off x="2163921" y="1325880"/>
+            <a:ext cx="7861110" cy="4937760"/>
+          </a:xfrm>
+          <a:prstGeom prst="rect">
+            <a:avLst/>
+          </a:prstGeom>
+        </p:spPr>
+      </p:pic>
+      <p:sp>
+        <p:nvSpPr>
+          <p:cNvPr id="8" name="Rectangle 7"/>
           <p:cNvSpPr/>
           <p:nvPr/>
         </p:nvSpPr>
@@ -9882,7 +8778,7 @@
       </p:sp>
       <p:sp>
         <p:nvSpPr>
-          <p:cNvPr id="10" name="TextBox 9"/>
+          <p:cNvPr id="9" name="TextBox 8"/>
           <p:cNvSpPr txBox="1"/>
           <p:nvPr/>
         </p:nvSpPr>
@@ -9911,6 +8807,41 @@
                 <a:latin typeface="Consolas"/>
               </a:rPr>
               <a:t>FKB Campus  ·  M17</a:t>
+            </a:r>
+          </a:p>
+        </p:txBody>
+      </p:sp>
+      <p:sp>
+        <p:nvSpPr>
+          <p:cNvPr id="10" name="TextBox 9"/>
+          <p:cNvSpPr txBox="1"/>
+          <p:nvPr/>
+        </p:nvSpPr>
+        <p:spPr>
+          <a:xfrm>
+            <a:off x="7176211" y="6583680"/>
+            <a:ext cx="4326940" cy="256032"/>
+          </a:xfrm>
+          <a:prstGeom prst="rect">
+            <a:avLst/>
+          </a:prstGeom>
+          <a:noFill/>
+        </p:spPr>
+        <p:txBody>
+          <a:bodyPr wrap="none">
+            <a:spAutoFit/>
+          </a:bodyPr>
+          <a:lstStyle/>
+          <a:p>
+            <a:pPr algn="r"/>
+            <a:r>
+              <a:rPr sz="700">
+                <a:solidFill>
+                  <a:srgbClr val="A0B4D2"/>
+                </a:solidFill>
+                <a:latin typeface="Consolas"/>
+              </a:rPr>
+              <a:t>Schaubild</a:t>
             </a:r>
           </a:p>
         </p:txBody>
@@ -10170,7 +9101,7 @@
                 </a:solidFill>
                 <a:latin typeface="Arial"/>
               </a:rPr>
-              <a:t>Phase 2: Während des Gesprächs</a:t>
+              <a:t>Der Gesprächsworkflow: Vor – Während – Nach</a:t>
             </a:r>
           </a:p>
         </p:txBody>
@@ -10196,6 +9127,25 @@
             <a:spAutoFit/>
           </a:bodyPr>
           <a:lstStyle/>
+          <a:p>
+            <a:pPr marL="177800" indent="-177800">
+              <a:spcBef>
+                <a:spcPts val="600"/>
+              </a:spcBef>
+              <a:spcAft>
+                <a:spcPts val="200"/>
+              </a:spcAft>
+            </a:pPr>
+            <a:r>
+              <a:rPr sz="1200" i="1">
+                <a:solidFill>
+                  <a:srgbClr val="3D5466"/>
+                </a:solidFill>
+                <a:latin typeface="Arial"/>
+              </a:rPr>
+              <a:t>→  Ein guter Workflow halbiert die Systemzeit – 15 statt 45 Minuten Vorbereitung, 10 statt 30 Minuten Nachbereitung.</a:t>
+            </a:r>
+          </a:p>
           <a:p>
             <a:pPr marL="190500" indent="-190500">
               <a:spcBef>
@@ -10212,7 +9162,7 @@
                 </a:solidFill>
                 <a:latin typeface="Arial"/>
               </a:rPr>
-              <a:t>▸  Kein separates Notizheft – direkt in agree</a:t>
+              <a:t>▸  Vorbereitung: Engagement, Anlässe und Vorjahresnotizen in agree bündeln.</a:t>
             </a:r>
           </a:p>
           <a:p>
@@ -10231,7 +9181,7 @@
                 </a:solidFill>
                 <a:latin typeface="Arial"/>
               </a:rPr>
-              <a:t>▸  Vereinbarungen sofort als Aktivität/Aufgabe anlegen (mit Datum und Verantwortlichkeit)</a:t>
+              <a:t>▸  Während des Gesprächs: strukturiert erfassen statt hinterher rekonstruieren.</a:t>
             </a:r>
           </a:p>
           <a:p>
@@ -10250,7 +9200,7 @@
                 </a:solidFill>
                 <a:latin typeface="Arial"/>
               </a:rPr>
-              <a:t>▸  Bedarfe in den dafür vorgesehenen Bedarfsfeldern des UnternehmerDialogs erfassen</a:t>
+              <a:t>▸  Nachbereitung: Vorgangsnotiz und Wiedervorlagen sofort setzen.</a:t>
             </a:r>
           </a:p>
         </p:txBody>
@@ -10588,7 +9538,7 @@
                 </a:solidFill>
                 <a:latin typeface="Arial"/>
               </a:rPr>
-              <a:t>Phase 3: Nachbereitung (10 Minuten statt 30 Minuten)</a:t>
+              <a:t>UnternehmerDialog: mehr als ein Formular</a:t>
             </a:r>
           </a:p>
         </p:txBody>
@@ -10614,6 +9564,25 @@
             <a:spAutoFit/>
           </a:bodyPr>
           <a:lstStyle/>
+          <a:p>
+            <a:pPr marL="177800" indent="-177800">
+              <a:spcBef>
+                <a:spcPts val="600"/>
+              </a:spcBef>
+              <a:spcAft>
+                <a:spcPts val="200"/>
+              </a:spcAft>
+            </a:pPr>
+            <a:r>
+              <a:rPr sz="1200" i="1">
+                <a:solidFill>
+                  <a:srgbClr val="3D5466"/>
+                </a:solidFill>
+                <a:latin typeface="Arial"/>
+              </a:rPr>
+              <a:t>→  Der UnternehmerDialog ist ein Bedarfsradar – richtig genutzt, öffnet er Gesprächsanlässe statt Häkchen zu verwalten.</a:t>
+            </a:r>
+          </a:p>
           <a:p>
             <a:pPr marL="190500" indent="-190500">
               <a:spcBef>
@@ -10630,7 +9599,26 @@
                 </a:solidFill>
                 <a:latin typeface="Arial"/>
               </a:rPr>
-              <a:t>▸  ## 4.3 UnternehmerDialog: Mehr als ein Formular</a:t>
+              <a:t>▸  Die Bedarfsdimensionen strukturieren das Gespräch entlang des Kundenbedarfs.</a:t>
+            </a:r>
+          </a:p>
+          <a:p>
+            <a:pPr marL="190500" indent="-190500">
+              <a:spcBef>
+                <a:spcPts val="400"/>
+              </a:spcBef>
+              <a:spcAft>
+                <a:spcPts val="200"/>
+              </a:spcAft>
+            </a:pPr>
+            <a:r>
+              <a:rPr sz="1300">
+                <a:solidFill>
+                  <a:srgbClr val="3D5466"/>
+                </a:solidFill>
+                <a:latin typeface="Arial"/>
+              </a:rPr>
+              <a:t>▸  Dokumentationsstandards sichern Revisionssicherheit und Vertretbarkeit.</a:t>
             </a:r>
           </a:p>
         </p:txBody>

</xml_diff>